<commit_message>
feat: atualizar apresentacao PowerPoint, novo fluxo de convidar amigo e envio de ingressos com QR Code por email
</commit_message>
<xml_diff>
--- a/Apresentacao_Horeb_Pastores.pptx
+++ b/Apresentacao_Horeb_Pastores.pptx
@@ -16,6 +16,8 @@
     <p:sldId id="264" r:id="rId15"/>
     <p:sldId id="265" r:id="rId16"/>
     <p:sldId id="266" r:id="rId17"/>
+    <p:sldId id="267" r:id="rId18"/>
+    <p:sldId id="268" r:id="rId19"/>
   </p:sldIdLst>
   <p:sldSz cx="12191695" cy="6858000" type="screen4x3"/>
   <p:notesSz cx="6858000" cy="9144000"/>
@@ -3143,7 +3145,7 @@
       </p:sp>
       <p:pic>
         <p:nvPicPr>
-          <p:cNvPr id="3" name="Picture 2" descr="horeb_apresentacao_capa_pt_1790726217722.jpg"/>
+          <p:cNvPr id="3" name="Picture 2" descr="capa.jpg"/>
           <p:cNvPicPr>
             <a:picLocks noChangeAspect="1"/>
           </p:cNvPicPr>
@@ -3173,8 +3175,8 @@
         </p:nvSpPr>
         <p:spPr>
           <a:xfrm>
-            <a:off x="731520" y="1097280"/>
-            <a:ext cx="4846320" cy="4754880"/>
+            <a:off x="731520" y="1051560"/>
+            <a:ext cx="4846320" cy="4846320"/>
           </a:xfrm>
           <a:prstGeom prst="rect">
             <a:avLst/>
@@ -3218,7 +3220,7 @@
           <a:p>
             <a:pPr>
               <a:spcAft>
-                <a:spcPts val="2400"/>
+                <a:spcPts val="2200"/>
               </a:spcAft>
               <a:defRPr sz="1600">
                 <a:solidFill>
@@ -3234,7 +3236,7 @@
           <a:p>
             <a:pPr>
               <a:spcAft>
-                <a:spcPts val="2000"/>
+                <a:spcPts val="1800"/>
               </a:spcAft>
               <a:defRPr sz="1300" i="1">
                 <a:solidFill>
@@ -3331,8 +3333,8 @@
         </p:nvSpPr>
         <p:spPr>
           <a:xfrm>
-            <a:off x="731520" y="457200"/>
-            <a:ext cx="10515600" cy="365760"/>
+            <a:off x="731520" y="411480"/>
+            <a:ext cx="10515600" cy="320040"/>
           </a:xfrm>
           <a:prstGeom prst="rect">
             <a:avLst/>
@@ -3367,7 +3369,7 @@
         </p:nvSpPr>
         <p:spPr>
           <a:xfrm>
-            <a:off x="731520" y="777240"/>
+            <a:off x="731520" y="731520"/>
             <a:ext cx="10515600" cy="731520"/>
           </a:xfrm>
           <a:prstGeom prst="rect">
@@ -3382,7 +3384,7 @@
           <a:lstStyle/>
           <a:p>
             <a:pPr>
-              <a:defRPr sz="2600" b="1">
+              <a:defRPr sz="2500" b="1">
                 <a:solidFill>
                   <a:srgbClr val="FFFFFF"/>
                 </a:solidFill>
@@ -3390,7 +3392,7 @@
               </a:defRPr>
             </a:pPr>
             <a:r>
-              <a:t>Cronograma de Implantação Rápida em 7 Dias</a:t>
+              <a:t>Eventos e Congressos: Bilheteria Digital, E-mail com QR Code &amp; Portaria</a:t>
             </a:r>
           </a:p>
         </p:txBody>
@@ -3403,8 +3405,8 @@
         </p:nvSpPr>
         <p:spPr>
           <a:xfrm>
-            <a:off x="731520" y="1828800"/>
-            <a:ext cx="2542032" cy="4297680"/>
+            <a:off x="731520" y="1691640"/>
+            <a:ext cx="5212080" cy="2011680"/>
           </a:xfrm>
           <a:prstGeom prst="roundRect">
             <a:avLst/>
@@ -3438,23 +3440,7 @@
           <a:p>
             <a:pPr algn="ctr">
               <a:spcAft>
-                <a:spcPts val="400"/>
-              </a:spcAft>
-              <a:defRPr sz="1300" b="1">
-                <a:solidFill>
-                  <a:srgbClr val="F59E0B"/>
-                </a:solidFill>
-                <a:latin typeface="Segoe UI"/>
-              </a:defRPr>
-            </a:pPr>
-            <a:r>
-              <a:t>Dias 1 e 2</a:t>
-            </a:r>
-          </a:p>
-          <a:p>
-            <a:pPr>
-              <a:spcAft>
-                <a:spcPts val="1200"/>
+                <a:spcPts val="600"/>
               </a:spcAft>
               <a:defRPr sz="1600" b="1">
                 <a:solidFill>
@@ -3464,12 +3450,12 @@
               </a:defRPr>
             </a:pPr>
             <a:r>
-              <a:t>Configuração Inicial</a:t>
-            </a:r>
-          </a:p>
-          <a:p>
-            <a:pPr>
-              <a:defRPr sz="1200">
+              <a:t>Inscrições e Vendas Sem Taxas</a:t>
+            </a:r>
+          </a:p>
+          <a:p>
+            <a:pPr>
+              <a:defRPr sz="1300">
                 <a:solidFill>
                   <a:srgbClr val="94A3B8"/>
                 </a:solidFill>
@@ -3477,7 +3463,7 @@
               </a:defRPr>
             </a:pPr>
             <a:r>
-              <a:t>Inclusão da logo da congregação, cadastro dos ministérios e escala de pastores.</a:t>
+              <a:t>Congressos de mulheres, retiros de jovens e conferências ministeriais (pagos ou gratuitos) com inscrição direta no aplicativo.</a:t>
             </a:r>
           </a:p>
         </p:txBody>
@@ -3490,8 +3476,79 @@
         </p:nvSpPr>
         <p:spPr>
           <a:xfrm>
-            <a:off x="3456432" y="1828800"/>
-            <a:ext cx="2542032" cy="4297680"/>
+            <a:off x="6217920" y="1691640"/>
+            <a:ext cx="5212080" cy="2011680"/>
+          </a:xfrm>
+          <a:prstGeom prst="roundRect">
+            <a:avLst/>
+          </a:prstGeom>
+          <a:solidFill>
+            <a:srgbClr val="121A2E"/>
+          </a:solidFill>
+          <a:ln w="19050">
+            <a:solidFill>
+              <a:srgbClr val="F59E0B"/>
+            </a:solidFill>
+          </a:ln>
+        </p:spPr>
+        <p:style>
+          <a:lnRef idx="1">
+            <a:schemeClr val="accent1"/>
+          </a:lnRef>
+          <a:fillRef idx="3">
+            <a:schemeClr val="accent1"/>
+          </a:fillRef>
+          <a:effectRef idx="2">
+            <a:schemeClr val="accent1"/>
+          </a:effectRef>
+          <a:fontRef idx="minor">
+            <a:schemeClr val="lt1"/>
+          </a:fontRef>
+        </p:style>
+        <p:txBody>
+          <a:bodyPr rtlCol="0" anchor="ctr" wrap="square"/>
+          <a:lstStyle/>
+          <a:p>
+            <a:pPr algn="ctr">
+              <a:spcAft>
+                <a:spcPts val="600"/>
+              </a:spcAft>
+              <a:defRPr sz="1600" b="1">
+                <a:solidFill>
+                  <a:srgbClr val="F59E0B"/>
+                </a:solidFill>
+                <a:latin typeface="Segoe UI"/>
+              </a:defRPr>
+            </a:pPr>
+            <a:r>
+              <a:t>Disparo Automático por E-mail</a:t>
+            </a:r>
+          </a:p>
+          <a:p>
+            <a:pPr>
+              <a:defRPr sz="1300">
+                <a:solidFill>
+                  <a:srgbClr val="94A3B8"/>
+                </a:solidFill>
+                <a:latin typeface="Segoe UI"/>
+              </a:defRPr>
+            </a:pPr>
+            <a:r>
+              <a:t>Ao confirmar o ingresso, o participante recebe e-mail oficial com o QR Code individualizado e código único de validação.</a:t>
+            </a:r>
+          </a:p>
+        </p:txBody>
+      </p:sp>
+      <p:sp>
+        <p:nvSpPr>
+          <p:cNvPr id="7" name="Rounded Rectangle 6"/>
+          <p:cNvSpPr/>
+          <p:nvPr/>
+        </p:nvSpPr>
+        <p:spPr>
+          <a:xfrm>
+            <a:off x="731520" y="3977639"/>
+            <a:ext cx="5212080" cy="2011680"/>
           </a:xfrm>
           <a:prstGeom prst="roundRect">
             <a:avLst/>
@@ -3525,23 +3582,7 @@
           <a:p>
             <a:pPr algn="ctr">
               <a:spcAft>
-                <a:spcPts val="400"/>
-              </a:spcAft>
-              <a:defRPr sz="1300" b="1">
-                <a:solidFill>
-                  <a:srgbClr val="F59E0B"/>
-                </a:solidFill>
-                <a:latin typeface="Segoe UI"/>
-              </a:defRPr>
-            </a:pPr>
-            <a:r>
-              <a:t>Dias 3 e 4</a:t>
-            </a:r>
-          </a:p>
-          <a:p>
-            <a:pPr>
-              <a:spcAft>
-                <a:spcPts val="1200"/>
+                <a:spcPts val="600"/>
               </a:spcAft>
               <a:defRPr sz="1600" b="1">
                 <a:solidFill>
@@ -3551,12 +3592,12 @@
               </a:defRPr>
             </a:pPr>
             <a:r>
-              <a:t>Treinamento Pastoral</a:t>
-            </a:r>
-          </a:p>
-          <a:p>
-            <a:pPr>
-              <a:defRPr sz="1200">
+              <a:t>Catraca Scanner em Segundos</a:t>
+            </a:r>
+          </a:p>
+          <a:p>
+            <a:pPr>
+              <a:defRPr sz="1300">
                 <a:solidFill>
                   <a:srgbClr val="94A3B8"/>
                 </a:solidFill>
@@ -3564,21 +3605,21 @@
               </a:defRPr>
             </a:pPr>
             <a:r>
-              <a:t>Capacitação prática da secretaria, tesouraria e equipe pastoral no painel.</a:t>
-            </a:r>
-          </a:p>
-        </p:txBody>
-      </p:sp>
-      <p:sp>
-        <p:nvSpPr>
-          <p:cNvPr id="7" name="Rounded Rectangle 6"/>
+              <a:t>Os obreiros e voluntários realizam a leitura do QR Code na entrada usando a própria câmera do celular, eliminando filas e tumultos.</a:t>
+            </a:r>
+          </a:p>
+        </p:txBody>
+      </p:sp>
+      <p:sp>
+        <p:nvSpPr>
+          <p:cNvPr id="8" name="Rounded Rectangle 7"/>
           <p:cNvSpPr/>
           <p:nvPr/>
         </p:nvSpPr>
         <p:spPr>
           <a:xfrm>
-            <a:off x="6181344" y="1828800"/>
-            <a:ext cx="2542032" cy="4297680"/>
+            <a:off x="6217920" y="3977639"/>
+            <a:ext cx="5212080" cy="2011680"/>
           </a:xfrm>
           <a:prstGeom prst="roundRect">
             <a:avLst/>
@@ -3612,23 +3653,7 @@
           <a:p>
             <a:pPr algn="ctr">
               <a:spcAft>
-                <a:spcPts val="400"/>
-              </a:spcAft>
-              <a:defRPr sz="1300" b="1">
-                <a:solidFill>
-                  <a:srgbClr val="F59E0B"/>
-                </a:solidFill>
-                <a:latin typeface="Segoe UI"/>
-              </a:defRPr>
-            </a:pPr>
-            <a:r>
-              <a:t>Dias 5 e 6</a:t>
-            </a:r>
-          </a:p>
-          <a:p>
-            <a:pPr>
-              <a:spcAft>
-                <a:spcPts val="1200"/>
+                <a:spcPts val="600"/>
               </a:spcAft>
               <a:defRPr sz="1600" b="1">
                 <a:solidFill>
@@ -3638,12 +3663,12 @@
               </a:defRPr>
             </a:pPr>
             <a:r>
-              <a:t>Cadastro de Células</a:t>
-            </a:r>
-          </a:p>
-          <a:p>
-            <a:pPr>
-              <a:defRPr sz="1200">
+              <a:t>Carteira Digital do Membro</a:t>
+            </a:r>
+          </a:p>
+          <a:p>
+            <a:pPr>
+              <a:defRPr sz="1300">
                 <a:solidFill>
                   <a:srgbClr val="94A3B8"/>
                 </a:solidFill>
@@ -3651,94 +3676,7 @@
               </a:defRPr>
             </a:pPr>
             <a:r>
-              <a:t>Inserção dos pequenos grupos e da agenda oficial de cultos e eventos.</a:t>
-            </a:r>
-          </a:p>
-        </p:txBody>
-      </p:sp>
-      <p:sp>
-        <p:nvSpPr>
-          <p:cNvPr id="8" name="Rounded Rectangle 7"/>
-          <p:cNvSpPr/>
-          <p:nvPr/>
-        </p:nvSpPr>
-        <p:spPr>
-          <a:xfrm>
-            <a:off x="8906256" y="1828800"/>
-            <a:ext cx="2542032" cy="4297680"/>
-          </a:xfrm>
-          <a:prstGeom prst="roundRect">
-            <a:avLst/>
-          </a:prstGeom>
-          <a:solidFill>
-            <a:srgbClr val="121A2E"/>
-          </a:solidFill>
-          <a:ln w="19050">
-            <a:solidFill>
-              <a:srgbClr val="F59E0B"/>
-            </a:solidFill>
-          </a:ln>
-        </p:spPr>
-        <p:style>
-          <a:lnRef idx="1">
-            <a:schemeClr val="accent1"/>
-          </a:lnRef>
-          <a:fillRef idx="3">
-            <a:schemeClr val="accent1"/>
-          </a:fillRef>
-          <a:effectRef idx="2">
-            <a:schemeClr val="accent1"/>
-          </a:effectRef>
-          <a:fontRef idx="minor">
-            <a:schemeClr val="lt1"/>
-          </a:fontRef>
-        </p:style>
-        <p:txBody>
-          <a:bodyPr rtlCol="0" anchor="ctr" wrap="square"/>
-          <a:lstStyle/>
-          <a:p>
-            <a:pPr algn="ctr">
-              <a:spcAft>
-                <a:spcPts val="400"/>
-              </a:spcAft>
-              <a:defRPr sz="1300" b="1">
-                <a:solidFill>
-                  <a:srgbClr val="F59E0B"/>
-                </a:solidFill>
-                <a:latin typeface="Segoe UI"/>
-              </a:defRPr>
-            </a:pPr>
-            <a:r>
-              <a:t>Dia 7</a:t>
-            </a:r>
-          </a:p>
-          <a:p>
-            <a:pPr>
-              <a:spcAft>
-                <a:spcPts val="1200"/>
-              </a:spcAft>
-              <a:defRPr sz="1600" b="1">
-                <a:solidFill>
-                  <a:srgbClr val="FFFFFF"/>
-                </a:solidFill>
-                <a:latin typeface="Segoe UI"/>
-              </a:defRPr>
-            </a:pPr>
-            <a:r>
-              <a:t>Lançamento no Culto</a:t>
-            </a:r>
-          </a:p>
-          <a:p>
-            <a:pPr>
-              <a:defRPr sz="1200">
-                <a:solidFill>
-                  <a:srgbClr val="94A3B8"/>
-                </a:solidFill>
-                <a:latin typeface="Segoe UI"/>
-              </a:defRPr>
-            </a:pPr>
-            <a:r>
-              <a:t>Apresentação com QR Code no telão do templo para toda a igreja baixar o app.</a:t>
+              <a:t>Todos os ingressos adquiridos ficam salvos na carteira digital do usuário no app para exibição offline a qualquer momento.</a:t>
             </a:r>
           </a:p>
         </p:txBody>
@@ -3806,6 +3744,904 @@
       </p:sp>
       <p:sp>
         <p:nvSpPr>
+          <p:cNvPr id="3" name="TextBox 2"/>
+          <p:cNvSpPr txBox="1"/>
+          <p:nvPr/>
+        </p:nvSpPr>
+        <p:spPr>
+          <a:xfrm>
+            <a:off x="731520" y="411480"/>
+            <a:ext cx="10515600" cy="320040"/>
+          </a:xfrm>
+          <a:prstGeom prst="rect">
+            <a:avLst/>
+          </a:prstGeom>
+          <a:noFill/>
+        </p:spPr>
+        <p:txBody>
+          <a:bodyPr wrap="square">
+            <a:spAutoFit/>
+          </a:bodyPr>
+          <a:lstStyle/>
+          <a:p>
+            <a:pPr>
+              <a:defRPr sz="1100" b="1">
+                <a:solidFill>
+                  <a:srgbClr val="F59E0B"/>
+                </a:solidFill>
+                <a:latin typeface="Segoe UI"/>
+              </a:defRPr>
+            </a:pPr>
+            <a:r>
+              <a:t>PLATAFORMA HOREB • APRESENTAÇÃO PASTORAL</a:t>
+            </a:r>
+          </a:p>
+        </p:txBody>
+      </p:sp>
+      <p:sp>
+        <p:nvSpPr>
+          <p:cNvPr id="4" name="TextBox 3"/>
+          <p:cNvSpPr txBox="1"/>
+          <p:nvPr/>
+        </p:nvSpPr>
+        <p:spPr>
+          <a:xfrm>
+            <a:off x="731520" y="731520"/>
+            <a:ext cx="10515600" cy="731520"/>
+          </a:xfrm>
+          <a:prstGeom prst="rect">
+            <a:avLst/>
+          </a:prstGeom>
+          <a:noFill/>
+        </p:spPr>
+        <p:txBody>
+          <a:bodyPr wrap="square">
+            <a:spAutoFit/>
+          </a:bodyPr>
+          <a:lstStyle/>
+          <a:p>
+            <a:pPr>
+              <a:defRPr sz="2500" b="1">
+                <a:solidFill>
+                  <a:srgbClr val="FFFFFF"/>
+                </a:solidFill>
+                <a:latin typeface="Segoe UI"/>
+              </a:defRPr>
+            </a:pPr>
+            <a:r>
+              <a:t>Governança em Rede: Sedes, Filiais e Segurança Multi-Tenant (RBAC)</a:t>
+            </a:r>
+          </a:p>
+        </p:txBody>
+      </p:sp>
+      <p:sp>
+        <p:nvSpPr>
+          <p:cNvPr id="5" name="Rounded Rectangle 4"/>
+          <p:cNvSpPr/>
+          <p:nvPr/>
+        </p:nvSpPr>
+        <p:spPr>
+          <a:xfrm>
+            <a:off x="731520" y="1691640"/>
+            <a:ext cx="5212080" cy="2011680"/>
+          </a:xfrm>
+          <a:prstGeom prst="roundRect">
+            <a:avLst/>
+          </a:prstGeom>
+          <a:solidFill>
+            <a:srgbClr val="121A2E"/>
+          </a:solidFill>
+          <a:ln w="19050">
+            <a:solidFill>
+              <a:srgbClr val="F59E0B"/>
+            </a:solidFill>
+          </a:ln>
+        </p:spPr>
+        <p:style>
+          <a:lnRef idx="1">
+            <a:schemeClr val="accent1"/>
+          </a:lnRef>
+          <a:fillRef idx="3">
+            <a:schemeClr val="accent1"/>
+          </a:fillRef>
+          <a:effectRef idx="2">
+            <a:schemeClr val="accent1"/>
+          </a:effectRef>
+          <a:fontRef idx="minor">
+            <a:schemeClr val="lt1"/>
+          </a:fontRef>
+        </p:style>
+        <p:txBody>
+          <a:bodyPr rtlCol="0" anchor="ctr" wrap="square"/>
+          <a:lstStyle/>
+          <a:p>
+            <a:pPr algn="ctr">
+              <a:spcAft>
+                <a:spcPts val="600"/>
+              </a:spcAft>
+              <a:defRPr sz="1600" b="1">
+                <a:solidFill>
+                  <a:srgbClr val="F59E0B"/>
+                </a:solidFill>
+                <a:latin typeface="Segoe UI"/>
+              </a:defRPr>
+            </a:pPr>
+            <a:r>
+              <a:t>Pastor Presidente / Bispo (Superadmin)</a:t>
+            </a:r>
+          </a:p>
+          <a:p>
+            <a:pPr>
+              <a:defRPr sz="1300">
+                <a:solidFill>
+                  <a:srgbClr val="94A3B8"/>
+                </a:solidFill>
+                <a:latin typeface="Segoe UI"/>
+              </a:defRPr>
+            </a:pPr>
+            <a:r>
+              <a:t>Visão panorâmica consolidada de toda a rede de congregações, relatórios globais de engajamento e troca ágil entre filiais.</a:t>
+            </a:r>
+          </a:p>
+        </p:txBody>
+      </p:sp>
+      <p:sp>
+        <p:nvSpPr>
+          <p:cNvPr id="6" name="Rounded Rectangle 5"/>
+          <p:cNvSpPr/>
+          <p:nvPr/>
+        </p:nvSpPr>
+        <p:spPr>
+          <a:xfrm>
+            <a:off x="6217920" y="1691640"/>
+            <a:ext cx="5212080" cy="2011680"/>
+          </a:xfrm>
+          <a:prstGeom prst="roundRect">
+            <a:avLst/>
+          </a:prstGeom>
+          <a:solidFill>
+            <a:srgbClr val="121A2E"/>
+          </a:solidFill>
+          <a:ln w="12700">
+            <a:solidFill>
+              <a:srgbClr val="263455"/>
+            </a:solidFill>
+          </a:ln>
+        </p:spPr>
+        <p:style>
+          <a:lnRef idx="1">
+            <a:schemeClr val="accent1"/>
+          </a:lnRef>
+          <a:fillRef idx="3">
+            <a:schemeClr val="accent1"/>
+          </a:fillRef>
+          <a:effectRef idx="2">
+            <a:schemeClr val="accent1"/>
+          </a:effectRef>
+          <a:fontRef idx="minor">
+            <a:schemeClr val="lt1"/>
+          </a:fontRef>
+        </p:style>
+        <p:txBody>
+          <a:bodyPr rtlCol="0" anchor="ctr" wrap="square"/>
+          <a:lstStyle/>
+          <a:p>
+            <a:pPr algn="ctr">
+              <a:spcAft>
+                <a:spcPts val="600"/>
+              </a:spcAft>
+              <a:defRPr sz="1600" b="1">
+                <a:solidFill>
+                  <a:srgbClr val="FFFFFF"/>
+                </a:solidFill>
+                <a:latin typeface="Segoe UI"/>
+              </a:defRPr>
+            </a:pPr>
+            <a:r>
+              <a:t>Pastores de Congregações Locais</a:t>
+            </a:r>
+          </a:p>
+          <a:p>
+            <a:pPr>
+              <a:defRPr sz="1300">
+                <a:solidFill>
+                  <a:srgbClr val="94A3B8"/>
+                </a:solidFill>
+                <a:latin typeface="Segoe UI"/>
+              </a:defRPr>
+            </a:pPr>
+            <a:r>
+              <a:t>Autonomia na gestão dos membros, aconselhamentos, células e eventos da sua congregação filial.</a:t>
+            </a:r>
+          </a:p>
+        </p:txBody>
+      </p:sp>
+      <p:sp>
+        <p:nvSpPr>
+          <p:cNvPr id="7" name="Rounded Rectangle 6"/>
+          <p:cNvSpPr/>
+          <p:nvPr/>
+        </p:nvSpPr>
+        <p:spPr>
+          <a:xfrm>
+            <a:off x="731520" y="3977639"/>
+            <a:ext cx="5212080" cy="2011680"/>
+          </a:xfrm>
+          <a:prstGeom prst="roundRect">
+            <a:avLst/>
+          </a:prstGeom>
+          <a:solidFill>
+            <a:srgbClr val="121A2E"/>
+          </a:solidFill>
+          <a:ln w="12700">
+            <a:solidFill>
+              <a:srgbClr val="263455"/>
+            </a:solidFill>
+          </a:ln>
+        </p:spPr>
+        <p:style>
+          <a:lnRef idx="1">
+            <a:schemeClr val="accent1"/>
+          </a:lnRef>
+          <a:fillRef idx="3">
+            <a:schemeClr val="accent1"/>
+          </a:fillRef>
+          <a:effectRef idx="2">
+            <a:schemeClr val="accent1"/>
+          </a:effectRef>
+          <a:fontRef idx="minor">
+            <a:schemeClr val="lt1"/>
+          </a:fontRef>
+        </p:style>
+        <p:txBody>
+          <a:bodyPr rtlCol="0" anchor="ctr" wrap="square"/>
+          <a:lstStyle/>
+          <a:p>
+            <a:pPr algn="ctr">
+              <a:spcAft>
+                <a:spcPts val="600"/>
+              </a:spcAft>
+              <a:defRPr sz="1600" b="1">
+                <a:solidFill>
+                  <a:srgbClr val="FFFFFF"/>
+                </a:solidFill>
+                <a:latin typeface="Segoe UI"/>
+              </a:defRPr>
+            </a:pPr>
+            <a:r>
+              <a:t>Tesouraria &amp; Conselho Fiscal</a:t>
+            </a:r>
+          </a:p>
+          <a:p>
+            <a:pPr>
+              <a:defRPr sz="1300">
+                <a:solidFill>
+                  <a:srgbClr val="94A3B8"/>
+                </a:solidFill>
+                <a:latin typeface="Segoe UI"/>
+              </a:defRPr>
+            </a:pPr>
+            <a:r>
+              <a:t>Acesso restrito aos módulos financeiros e prestação de contas, sem acesso a dados sigilosos pastorais.</a:t>
+            </a:r>
+          </a:p>
+        </p:txBody>
+      </p:sp>
+      <p:sp>
+        <p:nvSpPr>
+          <p:cNvPr id="8" name="Rounded Rectangle 7"/>
+          <p:cNvSpPr/>
+          <p:nvPr/>
+        </p:nvSpPr>
+        <p:spPr>
+          <a:xfrm>
+            <a:off x="6217920" y="3977639"/>
+            <a:ext cx="5212080" cy="2011680"/>
+          </a:xfrm>
+          <a:prstGeom prst="roundRect">
+            <a:avLst/>
+          </a:prstGeom>
+          <a:solidFill>
+            <a:srgbClr val="121A2E"/>
+          </a:solidFill>
+          <a:ln w="12700">
+            <a:solidFill>
+              <a:srgbClr val="263455"/>
+            </a:solidFill>
+          </a:ln>
+        </p:spPr>
+        <p:style>
+          <a:lnRef idx="1">
+            <a:schemeClr val="accent1"/>
+          </a:lnRef>
+          <a:fillRef idx="3">
+            <a:schemeClr val="accent1"/>
+          </a:fillRef>
+          <a:effectRef idx="2">
+            <a:schemeClr val="accent1"/>
+          </a:effectRef>
+          <a:fontRef idx="minor">
+            <a:schemeClr val="lt1"/>
+          </a:fontRef>
+        </p:style>
+        <p:txBody>
+          <a:bodyPr rtlCol="0" anchor="ctr" wrap="square"/>
+          <a:lstStyle/>
+          <a:p>
+            <a:pPr algn="ctr">
+              <a:spcAft>
+                <a:spcPts val="600"/>
+              </a:spcAft>
+              <a:defRPr sz="1600" b="1">
+                <a:solidFill>
+                  <a:srgbClr val="FFFFFF"/>
+                </a:solidFill>
+                <a:latin typeface="Segoe UI"/>
+              </a:defRPr>
+            </a:pPr>
+            <a:r>
+              <a:t>Líderes de Ministérios &amp; Membros</a:t>
+            </a:r>
+          </a:p>
+          <a:p>
+            <a:pPr>
+              <a:defRPr sz="1300">
+                <a:solidFill>
+                  <a:srgbClr val="94A3B8"/>
+                </a:solidFill>
+                <a:latin typeface="Segoe UI"/>
+              </a:defRPr>
+            </a:pPr>
+            <a:r>
+              <a:t>Gestão focada do seu próprio departamento, com membros acessando devocionais, células e seus próprios dízimos.</a:t>
+            </a:r>
+          </a:p>
+        </p:txBody>
+      </p:sp>
+    </p:spTree>
+  </p:cSld>
+  <p:clrMapOvr>
+    <a:masterClrMapping/>
+  </p:clrMapOvr>
+</p:sld>
+</file>
+
+<file path=ppt/slides/slide12.xml><?xml version="1.0" encoding="utf-8"?>
+<p:sld xmlns:a="http://schemas.openxmlformats.org/drawingml/2006/main" xmlns:p="http://schemas.openxmlformats.org/presentationml/2006/main" xmlns:r="http://schemas.openxmlformats.org/officeDocument/2006/relationships">
+  <p:cSld>
+    <p:spTree>
+      <p:nvGrpSpPr>
+        <p:cNvPr id="1" name=""/>
+        <p:cNvGrpSpPr/>
+        <p:nvPr/>
+      </p:nvGrpSpPr>
+      <p:grpSpPr/>
+      <p:sp>
+        <p:nvSpPr>
+          <p:cNvPr id="2" name="Rectangle 1"/>
+          <p:cNvSpPr/>
+          <p:nvPr/>
+        </p:nvSpPr>
+        <p:spPr>
+          <a:xfrm>
+            <a:off x="0" y="0"/>
+            <a:ext cx="12191695" cy="6858000"/>
+          </a:xfrm>
+          <a:prstGeom prst="rect">
+            <a:avLst/>
+          </a:prstGeom>
+          <a:solidFill>
+            <a:srgbClr val="0A0E1A"/>
+          </a:solidFill>
+          <a:ln>
+            <a:noFill/>
+          </a:ln>
+        </p:spPr>
+        <p:style>
+          <a:lnRef idx="1">
+            <a:schemeClr val="accent1"/>
+          </a:lnRef>
+          <a:fillRef idx="3">
+            <a:schemeClr val="accent1"/>
+          </a:fillRef>
+          <a:effectRef idx="2">
+            <a:schemeClr val="accent1"/>
+          </a:effectRef>
+          <a:fontRef idx="minor">
+            <a:schemeClr val="lt1"/>
+          </a:fontRef>
+        </p:style>
+        <p:txBody>
+          <a:bodyPr rtlCol="0" anchor="ctr"/>
+          <a:lstStyle/>
+          <a:p>
+            <a:pPr algn="ctr"/>
+          </a:p>
+        </p:txBody>
+      </p:sp>
+      <p:sp>
+        <p:nvSpPr>
+          <p:cNvPr id="3" name="TextBox 2"/>
+          <p:cNvSpPr txBox="1"/>
+          <p:nvPr/>
+        </p:nvSpPr>
+        <p:spPr>
+          <a:xfrm>
+            <a:off x="731520" y="411480"/>
+            <a:ext cx="10515600" cy="320040"/>
+          </a:xfrm>
+          <a:prstGeom prst="rect">
+            <a:avLst/>
+          </a:prstGeom>
+          <a:noFill/>
+        </p:spPr>
+        <p:txBody>
+          <a:bodyPr wrap="square">
+            <a:spAutoFit/>
+          </a:bodyPr>
+          <a:lstStyle/>
+          <a:p>
+            <a:pPr>
+              <a:defRPr sz="1100" b="1">
+                <a:solidFill>
+                  <a:srgbClr val="F59E0B"/>
+                </a:solidFill>
+                <a:latin typeface="Segoe UI"/>
+              </a:defRPr>
+            </a:pPr>
+            <a:r>
+              <a:t>PLATAFORMA HOREB • APRESENTAÇÃO PASTORAL</a:t>
+            </a:r>
+          </a:p>
+        </p:txBody>
+      </p:sp>
+      <p:sp>
+        <p:nvSpPr>
+          <p:cNvPr id="4" name="TextBox 3"/>
+          <p:cNvSpPr txBox="1"/>
+          <p:nvPr/>
+        </p:nvSpPr>
+        <p:spPr>
+          <a:xfrm>
+            <a:off x="731520" y="731520"/>
+            <a:ext cx="10515600" cy="731520"/>
+          </a:xfrm>
+          <a:prstGeom prst="rect">
+            <a:avLst/>
+          </a:prstGeom>
+          <a:noFill/>
+        </p:spPr>
+        <p:txBody>
+          <a:bodyPr wrap="square">
+            <a:spAutoFit/>
+          </a:bodyPr>
+          <a:lstStyle/>
+          <a:p>
+            <a:pPr>
+              <a:defRPr sz="2500" b="1">
+                <a:solidFill>
+                  <a:srgbClr val="FFFFFF"/>
+                </a:solidFill>
+                <a:latin typeface="Segoe UI"/>
+              </a:defRPr>
+            </a:pPr>
+            <a:r>
+              <a:t>Cronograma de Implantação Rápida em 7 Dias</a:t>
+            </a:r>
+          </a:p>
+        </p:txBody>
+      </p:sp>
+      <p:sp>
+        <p:nvSpPr>
+          <p:cNvPr id="5" name="Rounded Rectangle 4"/>
+          <p:cNvSpPr/>
+          <p:nvPr/>
+        </p:nvSpPr>
+        <p:spPr>
+          <a:xfrm>
+            <a:off x="731520" y="1783080"/>
+            <a:ext cx="2542032" cy="4297680"/>
+          </a:xfrm>
+          <a:prstGeom prst="roundRect">
+            <a:avLst/>
+          </a:prstGeom>
+          <a:solidFill>
+            <a:srgbClr val="121A2E"/>
+          </a:solidFill>
+          <a:ln w="12700">
+            <a:solidFill>
+              <a:srgbClr val="263455"/>
+            </a:solidFill>
+          </a:ln>
+        </p:spPr>
+        <p:style>
+          <a:lnRef idx="1">
+            <a:schemeClr val="accent1"/>
+          </a:lnRef>
+          <a:fillRef idx="3">
+            <a:schemeClr val="accent1"/>
+          </a:fillRef>
+          <a:effectRef idx="2">
+            <a:schemeClr val="accent1"/>
+          </a:effectRef>
+          <a:fontRef idx="minor">
+            <a:schemeClr val="lt1"/>
+          </a:fontRef>
+        </p:style>
+        <p:txBody>
+          <a:bodyPr rtlCol="0" anchor="ctr" wrap="square"/>
+          <a:lstStyle/>
+          <a:p>
+            <a:pPr algn="ctr">
+              <a:spcAft>
+                <a:spcPts val="400"/>
+              </a:spcAft>
+              <a:defRPr sz="1300" b="1">
+                <a:solidFill>
+                  <a:srgbClr val="F59E0B"/>
+                </a:solidFill>
+                <a:latin typeface="Segoe UI"/>
+              </a:defRPr>
+            </a:pPr>
+            <a:r>
+              <a:t>Dias 1 e 2</a:t>
+            </a:r>
+          </a:p>
+          <a:p>
+            <a:pPr>
+              <a:spcAft>
+                <a:spcPts val="1200"/>
+              </a:spcAft>
+              <a:defRPr sz="1600" b="1">
+                <a:solidFill>
+                  <a:srgbClr val="FFFFFF"/>
+                </a:solidFill>
+                <a:latin typeface="Segoe UI"/>
+              </a:defRPr>
+            </a:pPr>
+            <a:r>
+              <a:t>Configuração Inicial</a:t>
+            </a:r>
+          </a:p>
+          <a:p>
+            <a:pPr>
+              <a:defRPr sz="1200">
+                <a:solidFill>
+                  <a:srgbClr val="94A3B8"/>
+                </a:solidFill>
+                <a:latin typeface="Segoe UI"/>
+              </a:defRPr>
+            </a:pPr>
+            <a:r>
+              <a:t>Inclusão da logo da congregação, cores institucionais, filiais e escala de pastores.</a:t>
+            </a:r>
+          </a:p>
+        </p:txBody>
+      </p:sp>
+      <p:sp>
+        <p:nvSpPr>
+          <p:cNvPr id="6" name="Rounded Rectangle 5"/>
+          <p:cNvSpPr/>
+          <p:nvPr/>
+        </p:nvSpPr>
+        <p:spPr>
+          <a:xfrm>
+            <a:off x="3456432" y="1783080"/>
+            <a:ext cx="2542032" cy="4297680"/>
+          </a:xfrm>
+          <a:prstGeom prst="roundRect">
+            <a:avLst/>
+          </a:prstGeom>
+          <a:solidFill>
+            <a:srgbClr val="121A2E"/>
+          </a:solidFill>
+          <a:ln w="12700">
+            <a:solidFill>
+              <a:srgbClr val="263455"/>
+            </a:solidFill>
+          </a:ln>
+        </p:spPr>
+        <p:style>
+          <a:lnRef idx="1">
+            <a:schemeClr val="accent1"/>
+          </a:lnRef>
+          <a:fillRef idx="3">
+            <a:schemeClr val="accent1"/>
+          </a:fillRef>
+          <a:effectRef idx="2">
+            <a:schemeClr val="accent1"/>
+          </a:effectRef>
+          <a:fontRef idx="minor">
+            <a:schemeClr val="lt1"/>
+          </a:fontRef>
+        </p:style>
+        <p:txBody>
+          <a:bodyPr rtlCol="0" anchor="ctr" wrap="square"/>
+          <a:lstStyle/>
+          <a:p>
+            <a:pPr algn="ctr">
+              <a:spcAft>
+                <a:spcPts val="400"/>
+              </a:spcAft>
+              <a:defRPr sz="1300" b="1">
+                <a:solidFill>
+                  <a:srgbClr val="F59E0B"/>
+                </a:solidFill>
+                <a:latin typeface="Segoe UI"/>
+              </a:defRPr>
+            </a:pPr>
+            <a:r>
+              <a:t>Dias 3 e 4</a:t>
+            </a:r>
+          </a:p>
+          <a:p>
+            <a:pPr>
+              <a:spcAft>
+                <a:spcPts val="1200"/>
+              </a:spcAft>
+              <a:defRPr sz="1600" b="1">
+                <a:solidFill>
+                  <a:srgbClr val="FFFFFF"/>
+                </a:solidFill>
+                <a:latin typeface="Segoe UI"/>
+              </a:defRPr>
+            </a:pPr>
+            <a:r>
+              <a:t>Treinamento Pastoral</a:t>
+            </a:r>
+          </a:p>
+          <a:p>
+            <a:pPr>
+              <a:defRPr sz="1200">
+                <a:solidFill>
+                  <a:srgbClr val="94A3B8"/>
+                </a:solidFill>
+                <a:latin typeface="Segoe UI"/>
+              </a:defRPr>
+            </a:pPr>
+            <a:r>
+              <a:t>Capacitação prática da secretaria, tesouraria e equipe pastoral no painel.</a:t>
+            </a:r>
+          </a:p>
+        </p:txBody>
+      </p:sp>
+      <p:sp>
+        <p:nvSpPr>
+          <p:cNvPr id="7" name="Rounded Rectangle 6"/>
+          <p:cNvSpPr/>
+          <p:nvPr/>
+        </p:nvSpPr>
+        <p:spPr>
+          <a:xfrm>
+            <a:off x="6181344" y="1783080"/>
+            <a:ext cx="2542032" cy="4297680"/>
+          </a:xfrm>
+          <a:prstGeom prst="roundRect">
+            <a:avLst/>
+          </a:prstGeom>
+          <a:solidFill>
+            <a:srgbClr val="121A2E"/>
+          </a:solidFill>
+          <a:ln w="12700">
+            <a:solidFill>
+              <a:srgbClr val="263455"/>
+            </a:solidFill>
+          </a:ln>
+        </p:spPr>
+        <p:style>
+          <a:lnRef idx="1">
+            <a:schemeClr val="accent1"/>
+          </a:lnRef>
+          <a:fillRef idx="3">
+            <a:schemeClr val="accent1"/>
+          </a:fillRef>
+          <a:effectRef idx="2">
+            <a:schemeClr val="accent1"/>
+          </a:effectRef>
+          <a:fontRef idx="minor">
+            <a:schemeClr val="lt1"/>
+          </a:fontRef>
+        </p:style>
+        <p:txBody>
+          <a:bodyPr rtlCol="0" anchor="ctr" wrap="square"/>
+          <a:lstStyle/>
+          <a:p>
+            <a:pPr algn="ctr">
+              <a:spcAft>
+                <a:spcPts val="400"/>
+              </a:spcAft>
+              <a:defRPr sz="1300" b="1">
+                <a:solidFill>
+                  <a:srgbClr val="F59E0B"/>
+                </a:solidFill>
+                <a:latin typeface="Segoe UI"/>
+              </a:defRPr>
+            </a:pPr>
+            <a:r>
+              <a:t>Dias 5 e 6</a:t>
+            </a:r>
+          </a:p>
+          <a:p>
+            <a:pPr>
+              <a:spcAft>
+                <a:spcPts val="1200"/>
+              </a:spcAft>
+              <a:defRPr sz="1600" b="1">
+                <a:solidFill>
+                  <a:srgbClr val="FFFFFF"/>
+                </a:solidFill>
+                <a:latin typeface="Segoe UI"/>
+              </a:defRPr>
+            </a:pPr>
+            <a:r>
+              <a:t>Células e Ministérios</a:t>
+            </a:r>
+          </a:p>
+          <a:p>
+            <a:pPr>
+              <a:defRPr sz="1200">
+                <a:solidFill>
+                  <a:srgbClr val="94A3B8"/>
+                </a:solidFill>
+                <a:latin typeface="Segoe UI"/>
+              </a:defRPr>
+            </a:pPr>
+            <a:r>
+              <a:t>Inserção dos pequenos grupos, criação dos workspaces ministeriais e agenda.</a:t>
+            </a:r>
+          </a:p>
+        </p:txBody>
+      </p:sp>
+      <p:sp>
+        <p:nvSpPr>
+          <p:cNvPr id="8" name="Rounded Rectangle 7"/>
+          <p:cNvSpPr/>
+          <p:nvPr/>
+        </p:nvSpPr>
+        <p:spPr>
+          <a:xfrm>
+            <a:off x="8906256" y="1783080"/>
+            <a:ext cx="2542032" cy="4297680"/>
+          </a:xfrm>
+          <a:prstGeom prst="roundRect">
+            <a:avLst/>
+          </a:prstGeom>
+          <a:solidFill>
+            <a:srgbClr val="121A2E"/>
+          </a:solidFill>
+          <a:ln w="19050">
+            <a:solidFill>
+              <a:srgbClr val="F59E0B"/>
+            </a:solidFill>
+          </a:ln>
+        </p:spPr>
+        <p:style>
+          <a:lnRef idx="1">
+            <a:schemeClr val="accent1"/>
+          </a:lnRef>
+          <a:fillRef idx="3">
+            <a:schemeClr val="accent1"/>
+          </a:fillRef>
+          <a:effectRef idx="2">
+            <a:schemeClr val="accent1"/>
+          </a:effectRef>
+          <a:fontRef idx="minor">
+            <a:schemeClr val="lt1"/>
+          </a:fontRef>
+        </p:style>
+        <p:txBody>
+          <a:bodyPr rtlCol="0" anchor="ctr" wrap="square"/>
+          <a:lstStyle/>
+          <a:p>
+            <a:pPr algn="ctr">
+              <a:spcAft>
+                <a:spcPts val="400"/>
+              </a:spcAft>
+              <a:defRPr sz="1300" b="1">
+                <a:solidFill>
+                  <a:srgbClr val="F59E0B"/>
+                </a:solidFill>
+                <a:latin typeface="Segoe UI"/>
+              </a:defRPr>
+            </a:pPr>
+            <a:r>
+              <a:t>Dia 7</a:t>
+            </a:r>
+          </a:p>
+          <a:p>
+            <a:pPr>
+              <a:spcAft>
+                <a:spcPts val="1200"/>
+              </a:spcAft>
+              <a:defRPr sz="1600" b="1">
+                <a:solidFill>
+                  <a:srgbClr val="FFFFFF"/>
+                </a:solidFill>
+                <a:latin typeface="Segoe UI"/>
+              </a:defRPr>
+            </a:pPr>
+            <a:r>
+              <a:t>Lançamento no Culto</a:t>
+            </a:r>
+          </a:p>
+          <a:p>
+            <a:pPr>
+              <a:defRPr sz="1200">
+                <a:solidFill>
+                  <a:srgbClr val="94A3B8"/>
+                </a:solidFill>
+                <a:latin typeface="Segoe UI"/>
+              </a:defRPr>
+            </a:pPr>
+            <a:r>
+              <a:t>Apresentação com QR Code no telão do templo para toda a igreja baixar o app.</a:t>
+            </a:r>
+          </a:p>
+        </p:txBody>
+      </p:sp>
+    </p:spTree>
+  </p:cSld>
+  <p:clrMapOvr>
+    <a:masterClrMapping/>
+  </p:clrMapOvr>
+</p:sld>
+</file>
+
+<file path=ppt/slides/slide13.xml><?xml version="1.0" encoding="utf-8"?>
+<p:sld xmlns:a="http://schemas.openxmlformats.org/drawingml/2006/main" xmlns:p="http://schemas.openxmlformats.org/presentationml/2006/main" xmlns:r="http://schemas.openxmlformats.org/officeDocument/2006/relationships">
+  <p:cSld>
+    <p:spTree>
+      <p:nvGrpSpPr>
+        <p:cNvPr id="1" name=""/>
+        <p:cNvGrpSpPr/>
+        <p:nvPr/>
+      </p:nvGrpSpPr>
+      <p:grpSpPr/>
+      <p:sp>
+        <p:nvSpPr>
+          <p:cNvPr id="2" name="Rectangle 1"/>
+          <p:cNvSpPr/>
+          <p:nvPr/>
+        </p:nvSpPr>
+        <p:spPr>
+          <a:xfrm>
+            <a:off x="0" y="0"/>
+            <a:ext cx="12191695" cy="6858000"/>
+          </a:xfrm>
+          <a:prstGeom prst="rect">
+            <a:avLst/>
+          </a:prstGeom>
+          <a:solidFill>
+            <a:srgbClr val="0A0E1A"/>
+          </a:solidFill>
+          <a:ln>
+            <a:noFill/>
+          </a:ln>
+        </p:spPr>
+        <p:style>
+          <a:lnRef idx="1">
+            <a:schemeClr val="accent1"/>
+          </a:lnRef>
+          <a:fillRef idx="3">
+            <a:schemeClr val="accent1"/>
+          </a:fillRef>
+          <a:effectRef idx="2">
+            <a:schemeClr val="accent1"/>
+          </a:effectRef>
+          <a:fontRef idx="minor">
+            <a:schemeClr val="lt1"/>
+          </a:fontRef>
+        </p:style>
+        <p:txBody>
+          <a:bodyPr rtlCol="0" anchor="ctr"/>
+          <a:lstStyle/>
+          <a:p>
+            <a:pPr algn="ctr"/>
+          </a:p>
+        </p:txBody>
+      </p:sp>
+      <p:sp>
+        <p:nvSpPr>
           <p:cNvPr id="3" name="Rounded Rectangle 2"/>
           <p:cNvSpPr/>
           <p:nvPr/>
@@ -3988,8 +4824,8 @@
         </p:nvSpPr>
         <p:spPr>
           <a:xfrm>
-            <a:off x="731520" y="457200"/>
-            <a:ext cx="10515600" cy="365760"/>
+            <a:off x="731520" y="411480"/>
+            <a:ext cx="10515600" cy="320040"/>
           </a:xfrm>
           <a:prstGeom prst="rect">
             <a:avLst/>
@@ -4024,7 +4860,7 @@
         </p:nvSpPr>
         <p:spPr>
           <a:xfrm>
-            <a:off x="731520" y="777240"/>
+            <a:off x="731520" y="731520"/>
             <a:ext cx="10515600" cy="731520"/>
           </a:xfrm>
           <a:prstGeom prst="rect">
@@ -4039,7 +4875,7 @@
           <a:lstStyle/>
           <a:p>
             <a:pPr>
-              <a:defRPr sz="2600" b="1">
+              <a:defRPr sz="2500" b="1">
                 <a:solidFill>
                   <a:srgbClr val="FFFFFF"/>
                 </a:solidFill>
@@ -4060,7 +4896,7 @@
         </p:nvSpPr>
         <p:spPr>
           <a:xfrm>
-            <a:off x="731520" y="1645920"/>
+            <a:off x="731520" y="1600200"/>
             <a:ext cx="10725912" cy="1188720"/>
           </a:xfrm>
           <a:prstGeom prst="roundRect">
@@ -4128,8 +4964,8 @@
         </p:nvSpPr>
         <p:spPr>
           <a:xfrm>
-            <a:off x="731520" y="3108960"/>
-            <a:ext cx="3410712" cy="3017520"/>
+            <a:off x="731520" y="3063240"/>
+            <a:ext cx="3410712" cy="3108960"/>
           </a:xfrm>
           <a:prstGeom prst="roundRect">
             <a:avLst/>
@@ -4215,8 +5051,8 @@
         </p:nvSpPr>
         <p:spPr>
           <a:xfrm>
-            <a:off x="4389120" y="3108960"/>
-            <a:ext cx="3410712" cy="3017520"/>
+            <a:off x="4389120" y="3063240"/>
+            <a:ext cx="3410712" cy="3108960"/>
           </a:xfrm>
           <a:prstGeom prst="roundRect">
             <a:avLst/>
@@ -4302,8 +5138,8 @@
         </p:nvSpPr>
         <p:spPr>
           <a:xfrm>
-            <a:off x="8046720" y="3108960"/>
-            <a:ext cx="3410712" cy="3017520"/>
+            <a:off x="8046720" y="3063240"/>
+            <a:ext cx="3410712" cy="3108960"/>
           </a:xfrm>
           <a:prstGeom prst="roundRect">
             <a:avLst/>
@@ -4376,7 +5212,7 @@
               </a:defRPr>
             </a:pPr>
             <a:r>
-              <a:t>Dificuldade em acompanhar a frequência das células nos lares e emitir comprovantes confiáveis de dízimos para a declaração de Imposto de Renda.</a:t>
+              <a:t>Dificuldade em acompanhar a frequência das células nos lares, tarefas de departamentos e emitir comprovantes confiáveis de dízimos para IRPF.</a:t>
             </a:r>
           </a:p>
         </p:txBody>
@@ -4450,8 +5286,8 @@
         </p:nvSpPr>
         <p:spPr>
           <a:xfrm>
-            <a:off x="731520" y="457200"/>
-            <a:ext cx="10515600" cy="365760"/>
+            <a:off x="731520" y="411480"/>
+            <a:ext cx="10515600" cy="320040"/>
           </a:xfrm>
           <a:prstGeom prst="rect">
             <a:avLst/>
@@ -4486,7 +5322,7 @@
         </p:nvSpPr>
         <p:spPr>
           <a:xfrm>
-            <a:off x="731520" y="777240"/>
+            <a:off x="731520" y="731520"/>
             <a:ext cx="10515600" cy="731520"/>
           </a:xfrm>
           <a:prstGeom prst="rect">
@@ -4501,7 +5337,7 @@
           <a:lstStyle/>
           <a:p>
             <a:pPr>
-              <a:defRPr sz="2600" b="1">
+              <a:defRPr sz="2500" b="1">
                 <a:solidFill>
                   <a:srgbClr val="FFFFFF"/>
                 </a:solidFill>
@@ -4580,7 +5416,7 @@
               </a:defRPr>
             </a:pPr>
             <a:r>
-              <a:t>Aconselhamento bíblico com Inteligência Artificial humanizada que escuta, ora pelo membro e identifica crises emocionais em tempo real.</a:t>
+              <a:t>Aconselhamento bíblico com Inteligência Artificial humanizada com voz que escuta, ora pelo membro e identifica crises emocionais em tempo real.</a:t>
             </a:r>
           </a:p>
         </p:txBody>
@@ -4638,7 +5474,7 @@
               </a:defRPr>
             </a:pPr>
             <a:r>
-              <a:t>02. Comunhão e Discipulado</a:t>
+              <a:t>02. Comunhão, Departamentos e Células</a:t>
             </a:r>
           </a:p>
           <a:p>
@@ -4651,7 +5487,7 @@
               </a:defRPr>
             </a:pPr>
             <a:r>
-              <a:t>Localização de células nos lares, vídeos oficiais dos cultos, devocionais diários com áudio e integração ativa dos novos convertidos.</a:t>
+              <a:t>Workspaces de ministérios com atas e tarefas, localização de células nos lares, devocionais diários com áudio e convite nominal de amigos.</a:t>
             </a:r>
           </a:p>
         </p:txBody>
@@ -4709,7 +5545,7 @@
               </a:defRPr>
             </a:pPr>
             <a:r>
-              <a:t>03. Governança e Transparência</a:t>
+              <a:t>03. Governança, Eventos e Transparência</a:t>
             </a:r>
           </a:p>
           <a:p>
@@ -4722,7 +5558,7 @@
               </a:defRPr>
             </a:pPr>
             <a:r>
-              <a:t>Gestão financeira segura com dízimos nominais para IRPF, inscrições de congressos com QR Code e permissões por perfil ministerial.</a:t>
+              <a:t>Gestão financeira com dízimos nominais para IRPF, bilheteria com QR Code e envio automático de ingressos por e-mail, e controle multi-tenant de congregações.</a:t>
             </a:r>
           </a:p>
         </p:txBody>
@@ -4796,8 +5632,8 @@
         </p:nvSpPr>
         <p:spPr>
           <a:xfrm>
-            <a:off x="731520" y="457200"/>
-            <a:ext cx="10515600" cy="365760"/>
+            <a:off x="731520" y="411480"/>
+            <a:ext cx="10515600" cy="320040"/>
           </a:xfrm>
           <a:prstGeom prst="rect">
             <a:avLst/>
@@ -4832,7 +5668,7 @@
         </p:nvSpPr>
         <p:spPr>
           <a:xfrm>
-            <a:off x="731520" y="777240"/>
+            <a:off x="731520" y="731520"/>
             <a:ext cx="10515600" cy="731520"/>
           </a:xfrm>
           <a:prstGeom prst="rect">
@@ -4847,7 +5683,7 @@
           <a:lstStyle/>
           <a:p>
             <a:pPr>
-              <a:defRPr sz="2600" b="1">
+              <a:defRPr sz="2500" b="1">
                 <a:solidFill>
                   <a:srgbClr val="FFFFFF"/>
                 </a:solidFill>
@@ -4862,7 +5698,7 @@
       </p:sp>
       <p:pic>
         <p:nvPicPr>
-          <p:cNvPr id="5" name="Picture 4" descr="painel_pastoral_pt_1790726242788.jpg"/>
+          <p:cNvPr id="5" name="Picture 4" descr="painel_pastoral.jpg"/>
           <p:cNvPicPr>
             <a:picLocks noChangeAspect="1"/>
           </p:cNvPicPr>
@@ -4892,8 +5728,8 @@
         </p:nvSpPr>
         <p:spPr>
           <a:xfrm>
-            <a:off x="731520" y="1554480"/>
-            <a:ext cx="4480560" cy="4572000"/>
+            <a:off x="731520" y="1508760"/>
+            <a:ext cx="4480560" cy="4663440"/>
           </a:xfrm>
           <a:prstGeom prst="rect">
             <a:avLst/>
@@ -4924,7 +5760,7 @@
           <a:p>
             <a:pPr>
               <a:spcAft>
-                <a:spcPts val="1200"/>
+                <a:spcPts val="1000"/>
               </a:spcAft>
               <a:defRPr sz="1200">
                 <a:solidFill>
@@ -4934,7 +5770,7 @@
               </a:defRPr>
             </a:pPr>
             <a:r>
-              <a:t>O membro escolhe como se sente (Feliz &amp; Grato, Cansado, Ansioso, Triste) com design respeitoso e acolhedor.</a:t>
+              <a:t>O membro escolhe como se sente (Feliz, Grato, Cansado, Ansioso, Triste) com design respeitoso e acolhedor.</a:t>
             </a:r>
           </a:p>
           <a:p>
@@ -4956,7 +5792,7 @@
           <a:p>
             <a:pPr>
               <a:spcAft>
-                <a:spcPts val="1200"/>
+                <a:spcPts val="1000"/>
               </a:spcAft>
               <a:defRPr sz="1200">
                 <a:solidFill>
@@ -4966,7 +5802,7 @@
               </a:defRPr>
             </a:pPr>
             <a:r>
-              <a:t>A IA reconhece o primeiro nome do membro (ex: 'Graça e Paz, Luan!'), oferecendo leitura sensível e pastoral.</a:t>
+              <a:t>A IA reconhece o primeiro nome do membro (ex: 'Graça e Paz, irmão Luan!'), oferecendo leitura sensível e pastoral.</a:t>
             </a:r>
           </a:p>
           <a:p>
@@ -4982,13 +5818,13 @@
               </a:defRPr>
             </a:pPr>
             <a:r>
-              <a:t>Ouvir o Áudio a Qualquer Instante:</a:t>
+              <a:t>Player de Áudio Nativo (Voz Brasileira):</a:t>
             </a:r>
           </a:p>
           <a:p>
             <a:pPr>
               <a:spcAft>
-                <a:spcPts val="1200"/>
+                <a:spcPts val="1000"/>
               </a:spcAft>
               <a:defRPr sz="1200">
                 <a:solidFill>
@@ -4998,7 +5834,7 @@
               </a:defRPr>
             </a:pPr>
             <a:r>
-              <a:t>O usuário pode enviar sua mensagem gravando a própria voz e ouvir a resposta e a oração geradas em voz natural brasileira a qualquer hora.</a:t>
+              <a:t>O usuário pode escutar a meditação e a oração geradas em voz natural fluida a qualquer hora do dia ou da noite.</a:t>
             </a:r>
           </a:p>
           <a:p>
@@ -5014,13 +5850,13 @@
               </a:defRPr>
             </a:pPr>
             <a:r>
-              <a:t>Fiel à Doutrina Cristã:</a:t>
+              <a:t>100% Fiel à Doutrina Cristã:</a:t>
             </a:r>
           </a:p>
           <a:p>
             <a:pPr>
               <a:spcAft>
-                <a:spcPts val="1200"/>
+                <a:spcPts val="1000"/>
               </a:spcAft>
               <a:defRPr sz="1200">
                 <a:solidFill>
@@ -5030,7 +5866,7 @@
               </a:defRPr>
             </a:pPr>
             <a:r>
-              <a:t>Respostas estritamente embasadas nas Escrituras Sagradas, confortando sem frieza robótica.</a:t>
+              <a:t>Respostas estritamente embasadas nas Escrituras Sagradas, confortando sem frieza robótica ou conselhos seculares vazios.</a:t>
             </a:r>
           </a:p>
         </p:txBody>
@@ -5104,8 +5940,8 @@
         </p:nvSpPr>
         <p:spPr>
           <a:xfrm>
-            <a:off x="731520" y="457200"/>
-            <a:ext cx="10515600" cy="365760"/>
+            <a:off x="731520" y="411480"/>
+            <a:ext cx="10515600" cy="320040"/>
           </a:xfrm>
           <a:prstGeom prst="rect">
             <a:avLst/>
@@ -5140,7 +5976,7 @@
         </p:nvSpPr>
         <p:spPr>
           <a:xfrm>
-            <a:off x="731520" y="777240"/>
+            <a:off x="731520" y="731520"/>
             <a:ext cx="10515600" cy="731520"/>
           </a:xfrm>
           <a:prstGeom prst="rect">
@@ -5155,7 +5991,7 @@
           <a:lstStyle/>
           <a:p>
             <a:pPr>
-              <a:defRPr sz="2600" b="1">
+              <a:defRPr sz="2500" b="1">
                 <a:solidFill>
                   <a:srgbClr val="FFFFFF"/>
                 </a:solidFill>
@@ -5176,7 +6012,7 @@
         </p:nvSpPr>
         <p:spPr>
           <a:xfrm>
-            <a:off x="731520" y="1737360"/>
+            <a:off x="731520" y="1691640"/>
             <a:ext cx="5212080" cy="2011680"/>
           </a:xfrm>
           <a:prstGeom prst="roundRect">
@@ -5221,7 +6057,7 @@
               </a:defRPr>
             </a:pPr>
             <a:r>
-              <a:t>Passo 1: Acolhimento Diário</a:t>
+              <a:t>Passo 1: Acolhimento Diário 24/7</a:t>
             </a:r>
           </a:p>
           <a:p>
@@ -5234,7 +6070,7 @@
               </a:defRPr>
             </a:pPr>
             <a:r>
-              <a:t>A IA atua como primeiro apoio 24/7, consolando e intercedendo pelas situações rotineiras com a Palavra.</a:t>
+              <a:t>A IA atua como primeiro apoio contínuo, consolando e intercedendo pelas situações rotineiras com a Palavra.</a:t>
             </a:r>
           </a:p>
         </p:txBody>
@@ -5247,7 +6083,7 @@
         </p:nvSpPr>
         <p:spPr>
           <a:xfrm>
-            <a:off x="6217920" y="1737360"/>
+            <a:off x="6217920" y="1691640"/>
             <a:ext cx="5212080" cy="2011680"/>
           </a:xfrm>
           <a:prstGeom prst="roundRect">
@@ -5292,7 +6128,7 @@
               </a:defRPr>
             </a:pPr>
             <a:r>
-              <a:t>Passo 2: Detecção de Crise</a:t>
+              <a:t>Passo 2: Detecção Inteligente de Crise</a:t>
             </a:r>
           </a:p>
           <a:p>
@@ -5305,7 +6141,7 @@
               </a:defRPr>
             </a:pPr>
             <a:r>
-              <a:t>Em casos de luto, depressão severa ou crise familiar, o sistema aciona um botão de alerta: 'Falar com o Pastor'.</a:t>
+              <a:t>Em casos de luto, depressão severa ou conflito agudo, o sistema aciona um botão de alerta: 'Falar com o Pastor'.</a:t>
             </a:r>
           </a:p>
         </p:txBody>
@@ -5318,7 +6154,7 @@
         </p:nvSpPr>
         <p:spPr>
           <a:xfrm>
-            <a:off x="731520" y="4023360"/>
+            <a:off x="731520" y="3977639"/>
             <a:ext cx="5212080" cy="2011680"/>
           </a:xfrm>
           <a:prstGeom prst="roundRect">
@@ -5389,7 +6225,7 @@
         </p:nvSpPr>
         <p:spPr>
           <a:xfrm>
-            <a:off x="6217920" y="4023360"/>
+            <a:off x="6217920" y="3977639"/>
             <a:ext cx="5212080" cy="2011680"/>
           </a:xfrm>
           <a:prstGeom prst="roundRect">
@@ -5434,7 +6270,7 @@
               </a:defRPr>
             </a:pPr>
             <a:r>
-              <a:t>Passo 4: Preparo Espiritual Prévia</a:t>
+              <a:t>Passo 4: Preparo Espiritual Prévio</a:t>
             </a:r>
           </a:p>
           <a:p>
@@ -5521,8 +6357,8 @@
         </p:nvSpPr>
         <p:spPr>
           <a:xfrm>
-            <a:off x="731520" y="457200"/>
-            <a:ext cx="10515600" cy="365760"/>
+            <a:off x="731520" y="411480"/>
+            <a:ext cx="10515600" cy="320040"/>
           </a:xfrm>
           <a:prstGeom prst="rect">
             <a:avLst/>
@@ -5544,7 +6380,7 @@
               </a:defRPr>
             </a:pPr>
             <a:r>
-              <a:t>PLATAFORMA HOREB • APRESENTAÇÃO PASTORAL</a:t>
+              <a:t>DEPARTAMENTOS ECLESIAIS • GOVERNANÇA ATIVA</a:t>
             </a:r>
           </a:p>
         </p:txBody>
@@ -5557,7 +6393,7 @@
         </p:nvSpPr>
         <p:spPr>
           <a:xfrm>
-            <a:off x="731520" y="777240"/>
+            <a:off x="731520" y="731520"/>
             <a:ext cx="10515600" cy="731520"/>
           </a:xfrm>
           <a:prstGeom prst="rect">
@@ -5572,7 +6408,7 @@
           <a:lstStyle/>
           <a:p>
             <a:pPr>
-              <a:defRPr sz="2600" b="1">
+              <a:defRPr sz="2500" b="1">
                 <a:solidFill>
                   <a:srgbClr val="FFFFFF"/>
                 </a:solidFill>
@@ -5580,7 +6416,7 @@
               </a:defRPr>
             </a:pPr>
             <a:r>
-              <a:t>Células e Discipulado: A Igreja Conectada nos Lares</a:t>
+              <a:t>Gestão de Ministérios &amp; Departamentos: Workspaces Exclusivos</a:t>
             </a:r>
           </a:p>
         </p:txBody>
@@ -5593,8 +6429,79 @@
         </p:nvSpPr>
         <p:spPr>
           <a:xfrm>
-            <a:off x="731520" y="1737360"/>
-            <a:ext cx="10725912" cy="1280160"/>
+            <a:off x="731520" y="1691640"/>
+            <a:ext cx="5212080" cy="2011680"/>
+          </a:xfrm>
+          <a:prstGeom prst="roundRect">
+            <a:avLst/>
+          </a:prstGeom>
+          <a:solidFill>
+            <a:srgbClr val="121A2E"/>
+          </a:solidFill>
+          <a:ln w="19050">
+            <a:solidFill>
+              <a:srgbClr val="F59E0B"/>
+            </a:solidFill>
+          </a:ln>
+        </p:spPr>
+        <p:style>
+          <a:lnRef idx="1">
+            <a:schemeClr val="accent1"/>
+          </a:lnRef>
+          <a:fillRef idx="3">
+            <a:schemeClr val="accent1"/>
+          </a:fillRef>
+          <a:effectRef idx="2">
+            <a:schemeClr val="accent1"/>
+          </a:effectRef>
+          <a:fontRef idx="minor">
+            <a:schemeClr val="lt1"/>
+          </a:fontRef>
+        </p:style>
+        <p:txBody>
+          <a:bodyPr rtlCol="0" anchor="ctr" wrap="square"/>
+          <a:lstStyle/>
+          <a:p>
+            <a:pPr algn="ctr">
+              <a:spcAft>
+                <a:spcPts val="600"/>
+              </a:spcAft>
+              <a:defRPr sz="1600" b="1">
+                <a:solidFill>
+                  <a:srgbClr val="F59E0B"/>
+                </a:solidFill>
+                <a:latin typeface="Segoe UI"/>
+              </a:defRPr>
+            </a:pPr>
+            <a:r>
+              <a:t>Workspaces por Ministério</a:t>
+            </a:r>
+          </a:p>
+          <a:p>
+            <a:pPr>
+              <a:defRPr sz="1300">
+                <a:solidFill>
+                  <a:srgbClr val="94A3B8"/>
+                </a:solidFill>
+                <a:latin typeface="Segoe UI"/>
+              </a:defRPr>
+            </a:pPr>
+            <a:r>
+              <a:t>Espaço independente para Louvor, Jovens, Mulheres, Kids, Homens, Ação Social e Comunicação, com identidade própria.</a:t>
+            </a:r>
+          </a:p>
+        </p:txBody>
+      </p:sp>
+      <p:sp>
+        <p:nvSpPr>
+          <p:cNvPr id="6" name="Rounded Rectangle 5"/>
+          <p:cNvSpPr/>
+          <p:nvPr/>
+        </p:nvSpPr>
+        <p:spPr>
+          <a:xfrm>
+            <a:off x="6217920" y="1691640"/>
+            <a:ext cx="5212080" cy="2011680"/>
           </a:xfrm>
           <a:prstGeom prst="roundRect">
             <a:avLst/>
@@ -5628,17 +6535,17 @@
           <a:p>
             <a:pPr algn="ctr">
               <a:spcAft>
-                <a:spcPts val="400"/>
+                <a:spcPts val="600"/>
               </a:spcAft>
-              <a:defRPr sz="1700" b="1">
-                <a:solidFill>
-                  <a:srgbClr val="F59E0B"/>
-                </a:solidFill>
-                <a:latin typeface="Segoe UI"/>
-              </a:defRPr>
-            </a:pPr>
-            <a:r>
-              <a:t>Mapa da Igreja nos Bairros</a:t>
+              <a:defRPr sz="1600" b="1">
+                <a:solidFill>
+                  <a:srgbClr val="FFFFFF"/>
+                </a:solidFill>
+                <a:latin typeface="Segoe UI"/>
+              </a:defRPr>
+            </a:pPr>
+            <a:r>
+              <a:t>Atas de Reuniões Oficiais</a:t>
             </a:r>
           </a:p>
           <a:p>
@@ -5651,21 +6558,21 @@
               </a:defRPr>
             </a:pPr>
             <a:r>
-              <a:t>Visitantes e novos decididos encontram em 1 clique a célula mais próxima de sua casa, com endereço, dia, horário e contato do líder.</a:t>
-            </a:r>
-          </a:p>
-        </p:txBody>
-      </p:sp>
-      <p:sp>
-        <p:nvSpPr>
-          <p:cNvPr id="6" name="Rounded Rectangle 5"/>
+              <a:t>Registro digital de atas, decisões, aprovações e pautas das reuniões ministeriais, arquivadas em nuvem com histórico auditável.</a:t>
+            </a:r>
+          </a:p>
+        </p:txBody>
+      </p:sp>
+      <p:sp>
+        <p:nvSpPr>
+          <p:cNvPr id="7" name="Rounded Rectangle 6"/>
           <p:cNvSpPr/>
           <p:nvPr/>
         </p:nvSpPr>
         <p:spPr>
           <a:xfrm>
-            <a:off x="731520" y="3246120"/>
-            <a:ext cx="10725912" cy="1280160"/>
+            <a:off x="731520" y="3977639"/>
+            <a:ext cx="5212080" cy="2011680"/>
           </a:xfrm>
           <a:prstGeom prst="roundRect">
             <a:avLst/>
@@ -5699,17 +6606,17 @@
           <a:p>
             <a:pPr algn="ctr">
               <a:spcAft>
-                <a:spcPts val="400"/>
+                <a:spcPts val="600"/>
               </a:spcAft>
-              <a:defRPr sz="1700" b="1">
-                <a:solidFill>
-                  <a:srgbClr val="F59E0B"/>
-                </a:solidFill>
-                <a:latin typeface="Segoe UI"/>
-              </a:defRPr>
-            </a:pPr>
-            <a:r>
-              <a:t>Alinhamento Doutrinário Oficial</a:t>
+              <a:defRPr sz="1600" b="1">
+                <a:solidFill>
+                  <a:srgbClr val="FFFFFF"/>
+                </a:solidFill>
+                <a:latin typeface="Segoe UI"/>
+              </a:defRPr>
+            </a:pPr>
+            <a:r>
+              <a:t>Gestão de Tarefas &amp; Escalas</a:t>
             </a:r>
           </a:p>
           <a:p>
@@ -5722,21 +6629,21 @@
               </a:defRPr>
             </a:pPr>
             <a:r>
-              <a:t>Os líderes de célula acessam diretamente no aplicativo os estudos e esboços oficiais enviados pela liderança pastoral da igreja.</a:t>
-            </a:r>
-          </a:p>
-        </p:txBody>
-      </p:sp>
-      <p:sp>
-        <p:nvSpPr>
-          <p:cNvPr id="7" name="Rounded Rectangle 6"/>
+              <a:t>Distribuição clara de atividades, prazos e responsabilidades entre voluntários e obreiros, sem desencontro de informações.</a:t>
+            </a:r>
+          </a:p>
+        </p:txBody>
+      </p:sp>
+      <p:sp>
+        <p:nvSpPr>
+          <p:cNvPr id="8" name="Rounded Rectangle 7"/>
           <p:cNvSpPr/>
           <p:nvPr/>
         </p:nvSpPr>
         <p:spPr>
           <a:xfrm>
-            <a:off x="731520" y="4754879"/>
-            <a:ext cx="10725912" cy="1280160"/>
+            <a:off x="6217920" y="3977639"/>
+            <a:ext cx="5212080" cy="2011680"/>
           </a:xfrm>
           <a:prstGeom prst="roundRect">
             <a:avLst/>
@@ -5770,17 +6677,17 @@
           <a:p>
             <a:pPr algn="ctr">
               <a:spcAft>
-                <a:spcPts val="400"/>
+                <a:spcPts val="600"/>
               </a:spcAft>
-              <a:defRPr sz="1700" b="1">
-                <a:solidFill>
-                  <a:srgbClr val="F59E0B"/>
-                </a:solidFill>
-                <a:latin typeface="Segoe UI"/>
-              </a:defRPr>
-            </a:pPr>
-            <a:r>
-              <a:t>Frequência e Acompanhamento</a:t>
+              <a:defRPr sz="1600" b="1">
+                <a:solidFill>
+                  <a:srgbClr val="FFFFFF"/>
+                </a:solidFill>
+                <a:latin typeface="Segoe UI"/>
+              </a:defRPr>
+            </a:pPr>
+            <a:r>
+              <a:t>Equipe com Fotos e Lideranças</a:t>
             </a:r>
           </a:p>
           <a:p>
@@ -5793,7 +6700,7 @@
               </a:defRPr>
             </a:pPr>
             <a:r>
-              <a:t>O líder registra os membros presentes na reunião semanal, permitindo que a liderança pastoral saiba quem está faltando antes que esfrie na fé.</a:t>
+              <a:t>Visualização dos membros do departamento com fotos de perfil, telefones e funções bem definidas.</a:t>
             </a:r>
           </a:p>
         </p:txBody>
@@ -5867,8 +6774,8 @@
         </p:nvSpPr>
         <p:spPr>
           <a:xfrm>
-            <a:off x="731520" y="457200"/>
-            <a:ext cx="10515600" cy="365760"/>
+            <a:off x="731520" y="411480"/>
+            <a:ext cx="10515600" cy="320040"/>
           </a:xfrm>
           <a:prstGeom prst="rect">
             <a:avLst/>
@@ -5903,7 +6810,7 @@
         </p:nvSpPr>
         <p:spPr>
           <a:xfrm>
-            <a:off x="731520" y="777240"/>
+            <a:off x="731520" y="731520"/>
             <a:ext cx="10515600" cy="731520"/>
           </a:xfrm>
           <a:prstGeom prst="rect">
@@ -5918,7 +6825,7 @@
           <a:lstStyle/>
           <a:p>
             <a:pPr>
-              <a:defRPr sz="2600" b="1">
+              <a:defRPr sz="2500" b="1">
                 <a:solidFill>
                   <a:srgbClr val="FFFFFF"/>
                 </a:solidFill>
@@ -5926,62 +6833,128 @@
               </a:defRPr>
             </a:pPr>
             <a:r>
-              <a:t>Gestão Financeira Transparente &amp; Comprovantes de Dízimo para IRPF</a:t>
-            </a:r>
-          </a:p>
-        </p:txBody>
-      </p:sp>
-      <p:pic>
-        <p:nvPicPr>
-          <p:cNvPr id="5" name="Picture 4" descr="gestao_financeira_eventos_pt_1790726271005.jpg"/>
-          <p:cNvPicPr>
-            <a:picLocks noChangeAspect="1"/>
-          </p:cNvPicPr>
+              <a:t>Células e Discipulado: A Igreja Conectada nos Lares</a:t>
+            </a:r>
+          </a:p>
+        </p:txBody>
+      </p:sp>
+      <p:sp>
+        <p:nvSpPr>
+          <p:cNvPr id="5" name="Rounded Rectangle 4"/>
+          <p:cNvSpPr/>
           <p:nvPr/>
-        </p:nvPicPr>
-        <p:blipFill>
-          <a:blip r:embed="rId2"/>
-          <a:stretch>
-            <a:fillRect/>
-          </a:stretch>
-        </p:blipFill>
-        <p:spPr>
-          <a:xfrm>
-            <a:off x="5303520" y="1554480"/>
-            <a:ext cx="6126480" cy="4572000"/>
-          </a:xfrm>
-          <a:prstGeom prst="rect">
+        </p:nvSpPr>
+        <p:spPr>
+          <a:xfrm>
+            <a:off x="731520" y="1691640"/>
+            <a:ext cx="10725912" cy="1280160"/>
+          </a:xfrm>
+          <a:prstGeom prst="roundRect">
             <a:avLst/>
           </a:prstGeom>
-        </p:spPr>
-      </p:pic>
-      <p:sp>
-        <p:nvSpPr>
-          <p:cNvPr id="6" name="TextBox 5"/>
-          <p:cNvSpPr txBox="1"/>
+          <a:solidFill>
+            <a:srgbClr val="121A2E"/>
+          </a:solidFill>
+          <a:ln w="12700">
+            <a:solidFill>
+              <a:srgbClr val="263455"/>
+            </a:solidFill>
+          </a:ln>
+        </p:spPr>
+        <p:style>
+          <a:lnRef idx="1">
+            <a:schemeClr val="accent1"/>
+          </a:lnRef>
+          <a:fillRef idx="3">
+            <a:schemeClr val="accent1"/>
+          </a:fillRef>
+          <a:effectRef idx="2">
+            <a:schemeClr val="accent1"/>
+          </a:effectRef>
+          <a:fontRef idx="minor">
+            <a:schemeClr val="lt1"/>
+          </a:fontRef>
+        </p:style>
+        <p:txBody>
+          <a:bodyPr rtlCol="0" anchor="ctr" wrap="square"/>
+          <a:lstStyle/>
+          <a:p>
+            <a:pPr algn="ctr">
+              <a:spcAft>
+                <a:spcPts val="400"/>
+              </a:spcAft>
+              <a:defRPr sz="1700" b="1">
+                <a:solidFill>
+                  <a:srgbClr val="F59E0B"/>
+                </a:solidFill>
+                <a:latin typeface="Segoe UI"/>
+              </a:defRPr>
+            </a:pPr>
+            <a:r>
+              <a:t>Mapa da Igreja nos Bairros</a:t>
+            </a:r>
+          </a:p>
+          <a:p>
+            <a:pPr>
+              <a:defRPr sz="1300">
+                <a:solidFill>
+                  <a:srgbClr val="94A3B8"/>
+                </a:solidFill>
+                <a:latin typeface="Segoe UI"/>
+              </a:defRPr>
+            </a:pPr>
+            <a:r>
+              <a:t>Visitantes e novos decididos encontram em 1 clique a célula mais próxima de sua casa, com endereço, dia, horário e contato do líder.</a:t>
+            </a:r>
+          </a:p>
+        </p:txBody>
+      </p:sp>
+      <p:sp>
+        <p:nvSpPr>
+          <p:cNvPr id="6" name="Rounded Rectangle 5"/>
+          <p:cNvSpPr/>
           <p:nvPr/>
         </p:nvSpPr>
         <p:spPr>
           <a:xfrm>
-            <a:off x="731520" y="1554480"/>
-            <a:ext cx="4297680" cy="4572000"/>
-          </a:xfrm>
-          <a:prstGeom prst="rect">
+            <a:off x="731520" y="3200400"/>
+            <a:ext cx="10725912" cy="1280160"/>
+          </a:xfrm>
+          <a:prstGeom prst="roundRect">
             <a:avLst/>
           </a:prstGeom>
-          <a:noFill/>
-        </p:spPr>
-        <p:txBody>
-          <a:bodyPr wrap="square">
-            <a:spAutoFit/>
-          </a:bodyPr>
-          <a:lstStyle/>
-          <a:p>
-            <a:pPr>
+          <a:solidFill>
+            <a:srgbClr val="121A2E"/>
+          </a:solidFill>
+          <a:ln w="12700">
+            <a:solidFill>
+              <a:srgbClr val="263455"/>
+            </a:solidFill>
+          </a:ln>
+        </p:spPr>
+        <p:style>
+          <a:lnRef idx="1">
+            <a:schemeClr val="accent1"/>
+          </a:lnRef>
+          <a:fillRef idx="3">
+            <a:schemeClr val="accent1"/>
+          </a:fillRef>
+          <a:effectRef idx="2">
+            <a:schemeClr val="accent1"/>
+          </a:effectRef>
+          <a:fontRef idx="minor">
+            <a:schemeClr val="lt1"/>
+          </a:fontRef>
+        </p:style>
+        <p:txBody>
+          <a:bodyPr rtlCol="0" anchor="ctr" wrap="square"/>
+          <a:lstStyle/>
+          <a:p>
+            <a:pPr algn="ctr">
               <a:spcAft>
-                <a:spcPts val="200"/>
+                <a:spcPts val="400"/>
               </a:spcAft>
-              <a:defRPr sz="1400" b="1">
+              <a:defRPr sz="1700" b="1">
                 <a:solidFill>
                   <a:srgbClr val="F59E0B"/>
                 </a:solidFill>
@@ -5989,15 +6962,83 @@
               </a:defRPr>
             </a:pPr>
             <a:r>
-              <a:t>Dízimos e Ofertas Nominais:</a:t>
-            </a:r>
-          </a:p>
-          <a:p>
-            <a:pPr>
+              <a:t>Alinhamento Doutrinário Oficial</a:t>
+            </a:r>
+          </a:p>
+          <a:p>
+            <a:pPr>
+              <a:defRPr sz="1300">
+                <a:solidFill>
+                  <a:srgbClr val="94A3B8"/>
+                </a:solidFill>
+                <a:latin typeface="Segoe UI"/>
+              </a:defRPr>
+            </a:pPr>
+            <a:r>
+              <a:t>Os líderes de célula acessam diretamente no aplicativo os estudos e esboços oficiais enviados pela liderança pastoral da igreja.</a:t>
+            </a:r>
+          </a:p>
+        </p:txBody>
+      </p:sp>
+      <p:sp>
+        <p:nvSpPr>
+          <p:cNvPr id="7" name="Rounded Rectangle 6"/>
+          <p:cNvSpPr/>
+          <p:nvPr/>
+        </p:nvSpPr>
+        <p:spPr>
+          <a:xfrm>
+            <a:off x="731520" y="4709160"/>
+            <a:ext cx="10725912" cy="1280160"/>
+          </a:xfrm>
+          <a:prstGeom prst="roundRect">
+            <a:avLst/>
+          </a:prstGeom>
+          <a:solidFill>
+            <a:srgbClr val="121A2E"/>
+          </a:solidFill>
+          <a:ln w="12700">
+            <a:solidFill>
+              <a:srgbClr val="263455"/>
+            </a:solidFill>
+          </a:ln>
+        </p:spPr>
+        <p:style>
+          <a:lnRef idx="1">
+            <a:schemeClr val="accent1"/>
+          </a:lnRef>
+          <a:fillRef idx="3">
+            <a:schemeClr val="accent1"/>
+          </a:fillRef>
+          <a:effectRef idx="2">
+            <a:schemeClr val="accent1"/>
+          </a:effectRef>
+          <a:fontRef idx="minor">
+            <a:schemeClr val="lt1"/>
+          </a:fontRef>
+        </p:style>
+        <p:txBody>
+          <a:bodyPr rtlCol="0" anchor="ctr" wrap="square"/>
+          <a:lstStyle/>
+          <a:p>
+            <a:pPr algn="ctr">
               <a:spcAft>
-                <a:spcPts val="1200"/>
+                <a:spcPts val="400"/>
               </a:spcAft>
-              <a:defRPr sz="1200">
+              <a:defRPr sz="1700" b="1">
+                <a:solidFill>
+                  <a:srgbClr val="F59E0B"/>
+                </a:solidFill>
+                <a:latin typeface="Segoe UI"/>
+              </a:defRPr>
+            </a:pPr>
+            <a:r>
+              <a:t>Frequência e Acompanhamento</a:t>
+            </a:r>
+          </a:p>
+          <a:p>
+            <a:pPr>
+              <a:defRPr sz="1300">
                 <a:solidFill>
                   <a:srgbClr val="94A3B8"/>
                 </a:solidFill>
@@ -6005,103 +7046,7 @@
               </a:defRPr>
             </a:pPr>
             <a:r>
-              <a:t>Rastreamento seguro via PIX, cartão e transferências bancárias com identificação individual do membro.</a:t>
-            </a:r>
-          </a:p>
-          <a:p>
-            <a:pPr>
-              <a:spcAft>
-                <a:spcPts val="200"/>
-              </a:spcAft>
-              <a:defRPr sz="1400" b="1">
-                <a:solidFill>
-                  <a:srgbClr val="F59E0B"/>
-                </a:solidFill>
-                <a:latin typeface="Segoe UI"/>
-              </a:defRPr>
-            </a:pPr>
-            <a:r>
-              <a:t>Comprovante Anual para IRPF:</a:t>
-            </a:r>
-          </a:p>
-          <a:p>
-            <a:pPr>
-              <a:spcAft>
-                <a:spcPts val="1200"/>
-              </a:spcAft>
-              <a:defRPr sz="1200">
-                <a:solidFill>
-                  <a:srgbClr val="94A3B8"/>
-                </a:solidFill>
-                <a:latin typeface="Segoe UI"/>
-              </a:defRPr>
-            </a:pPr>
-            <a:r>
-              <a:t>Gera extrato oficial com CNPJ da igreja para a declaração de Imposto de Renda dos membros de forma imediata.</a:t>
-            </a:r>
-          </a:p>
-          <a:p>
-            <a:pPr>
-              <a:spcAft>
-                <a:spcPts val="200"/>
-              </a:spcAft>
-              <a:defRPr sz="1400" b="1">
-                <a:solidFill>
-                  <a:srgbClr val="F59E0B"/>
-                </a:solidFill>
-                <a:latin typeface="Segoe UI"/>
-              </a:defRPr>
-            </a:pPr>
-            <a:r>
-              <a:t>Transparência com a Diretoria:</a:t>
-            </a:r>
-          </a:p>
-          <a:p>
-            <a:pPr>
-              <a:spcAft>
-                <a:spcPts val="1200"/>
-              </a:spcAft>
-              <a:defRPr sz="1200">
-                <a:solidFill>
-                  <a:srgbClr val="94A3B8"/>
-                </a:solidFill>
-                <a:latin typeface="Segoe UI"/>
-              </a:defRPr>
-            </a:pPr>
-            <a:r>
-              <a:t>Relatórios mensais categorizados (Missões, Aluguel, Reforma, Obras Sociais) prontos para aprovação em assembleia.</a:t>
-            </a:r>
-          </a:p>
-          <a:p>
-            <a:pPr>
-              <a:spcAft>
-                <a:spcPts val="200"/>
-              </a:spcAft>
-              <a:defRPr sz="1400" b="1">
-                <a:solidFill>
-                  <a:srgbClr val="F59E0B"/>
-                </a:solidFill>
-                <a:latin typeface="Segoe UI"/>
-              </a:defRPr>
-            </a:pPr>
-            <a:r>
-              <a:t>Segurança Bancária:</a:t>
-            </a:r>
-          </a:p>
-          <a:p>
-            <a:pPr>
-              <a:spcAft>
-                <a:spcPts val="1200"/>
-              </a:spcAft>
-              <a:defRPr sz="1200">
-                <a:solidFill>
-                  <a:srgbClr val="94A3B8"/>
-                </a:solidFill>
-                <a:latin typeface="Segoe UI"/>
-              </a:defRPr>
-            </a:pPr>
-            <a:r>
-              <a:t>Sem manipulação manual desprotegida de dinheiro em espécie na tesouraria.</a:t>
+              <a:t>O líder registra os membros presentes na reunião semanal, permitindo que a liderança pastoral saiba quem está faltando antes que esfrie na fé.</a:t>
             </a:r>
           </a:p>
         </p:txBody>
@@ -6175,8 +7120,8 @@
         </p:nvSpPr>
         <p:spPr>
           <a:xfrm>
-            <a:off x="731520" y="457200"/>
-            <a:ext cx="10515600" cy="365760"/>
+            <a:off x="731520" y="411480"/>
+            <a:ext cx="10515600" cy="320040"/>
           </a:xfrm>
           <a:prstGeom prst="rect">
             <a:avLst/>
@@ -6198,7 +7143,7 @@
               </a:defRPr>
             </a:pPr>
             <a:r>
-              <a:t>PLATAFORMA HOREB • APRESENTAÇÃO PASTORAL</a:t>
+              <a:t>CRESCIMENTO DA IGREJA • ENGAJAMENTO</a:t>
             </a:r>
           </a:p>
         </p:txBody>
@@ -6211,7 +7156,7 @@
         </p:nvSpPr>
         <p:spPr>
           <a:xfrm>
-            <a:off x="731520" y="777240"/>
+            <a:off x="731520" y="731520"/>
             <a:ext cx="10515600" cy="731520"/>
           </a:xfrm>
           <a:prstGeom prst="rect">
@@ -6226,7 +7171,7 @@
           <a:lstStyle/>
           <a:p>
             <a:pPr>
-              <a:defRPr sz="2600" b="1">
+              <a:defRPr sz="2500" b="1">
                 <a:solidFill>
                   <a:srgbClr val="FFFFFF"/>
                 </a:solidFill>
@@ -6234,7 +7179,7 @@
               </a:defRPr>
             </a:pPr>
             <a:r>
-              <a:t>Eventos e Congressos: Ingressos Digitais e Credenciamento com QR Code</a:t>
+              <a:t>Multiplicação e Evangelismo: 'Convidar Amigo' em 1 Clique</a:t>
             </a:r>
           </a:p>
         </p:txBody>
@@ -6247,8 +7192,79 @@
         </p:nvSpPr>
         <p:spPr>
           <a:xfrm>
-            <a:off x="731520" y="1737360"/>
-            <a:ext cx="10725912" cy="1280160"/>
+            <a:off x="731520" y="1691640"/>
+            <a:ext cx="5212080" cy="2011680"/>
+          </a:xfrm>
+          <a:prstGeom prst="roundRect">
+            <a:avLst/>
+          </a:prstGeom>
+          <a:solidFill>
+            <a:srgbClr val="121A2E"/>
+          </a:solidFill>
+          <a:ln w="19050">
+            <a:solidFill>
+              <a:srgbClr val="F59E0B"/>
+            </a:solidFill>
+          </a:ln>
+        </p:spPr>
+        <p:style>
+          <a:lnRef idx="1">
+            <a:schemeClr val="accent1"/>
+          </a:lnRef>
+          <a:fillRef idx="3">
+            <a:schemeClr val="accent1"/>
+          </a:fillRef>
+          <a:effectRef idx="2">
+            <a:schemeClr val="accent1"/>
+          </a:effectRef>
+          <a:fontRef idx="minor">
+            <a:schemeClr val="lt1"/>
+          </a:fontRef>
+        </p:style>
+        <p:txBody>
+          <a:bodyPr rtlCol="0" anchor="ctr" wrap="square"/>
+          <a:lstStyle/>
+          <a:p>
+            <a:pPr algn="ctr">
+              <a:spcAft>
+                <a:spcPts val="600"/>
+              </a:spcAft>
+              <a:defRPr sz="1600" b="1">
+                <a:solidFill>
+                  <a:srgbClr val="F59E0B"/>
+                </a:solidFill>
+                <a:latin typeface="Segoe UI"/>
+              </a:defRPr>
+            </a:pPr>
+            <a:r>
+              <a:t>Convite Fácil via WhatsApp &amp; E-mail</a:t>
+            </a:r>
+          </a:p>
+          <a:p>
+            <a:pPr>
+              <a:defRPr sz="1300">
+                <a:solidFill>
+                  <a:srgbClr val="94A3B8"/>
+                </a:solidFill>
+                <a:latin typeface="Segoe UI"/>
+              </a:defRPr>
+            </a:pPr>
+            <a:r>
+              <a:t>Qualquer membro pode convidar vizinhos, amigos e familiares gerando um link acolhedor pré-preenchido com o nome do convidado.</a:t>
+            </a:r>
+          </a:p>
+        </p:txBody>
+      </p:sp>
+      <p:sp>
+        <p:nvSpPr>
+          <p:cNvPr id="6" name="Rounded Rectangle 5"/>
+          <p:cNvSpPr/>
+          <p:nvPr/>
+        </p:nvSpPr>
+        <p:spPr>
+          <a:xfrm>
+            <a:off x="6217920" y="1691640"/>
+            <a:ext cx="5212080" cy="2011680"/>
           </a:xfrm>
           <a:prstGeom prst="roundRect">
             <a:avLst/>
@@ -6282,17 +7298,17 @@
           <a:p>
             <a:pPr algn="ctr">
               <a:spcAft>
-                <a:spcPts val="400"/>
+                <a:spcPts val="600"/>
               </a:spcAft>
-              <a:defRPr sz="1700" b="1">
-                <a:solidFill>
-                  <a:srgbClr val="F59E0B"/>
-                </a:solidFill>
-                <a:latin typeface="Segoe UI"/>
-              </a:defRPr>
-            </a:pPr>
-            <a:r>
-              <a:t>Inscrições e Vendas Sem Intermediários</a:t>
+              <a:defRPr sz="1600" b="1">
+                <a:solidFill>
+                  <a:srgbClr val="FFFFFF"/>
+                </a:solidFill>
+                <a:latin typeface="Segoe UI"/>
+              </a:defRPr>
+            </a:pPr>
+            <a:r>
+              <a:t>Página de Boas-Vindas Desbloqueada</a:t>
             </a:r>
           </a:p>
           <a:p>
@@ -6305,21 +7321,21 @@
               </a:defRPr>
             </a:pPr>
             <a:r>
-              <a:t>Congressos de mulheres, retiros de jovens e conferências ministeriais (pagos ou gratuitos) com inscrição direta no aplicativo.</a:t>
-            </a:r>
-          </a:p>
-        </p:txBody>
-      </p:sp>
-      <p:sp>
-        <p:nvSpPr>
-          <p:cNvPr id="6" name="Rounded Rectangle 5"/>
+              <a:t>O amigo acessa uma tela limpa e elegante na web (/[slug]/cadastro) com a identidade visual e o logo da igreja, sem complicação.</a:t>
+            </a:r>
+          </a:p>
+        </p:txBody>
+      </p:sp>
+      <p:sp>
+        <p:nvSpPr>
+          <p:cNvPr id="7" name="Rounded Rectangle 6"/>
           <p:cNvSpPr/>
           <p:nvPr/>
         </p:nvSpPr>
         <p:spPr>
           <a:xfrm>
-            <a:off x="731520" y="3246120"/>
-            <a:ext cx="10725912" cy="1280160"/>
+            <a:off x="731520" y="3977639"/>
+            <a:ext cx="5212080" cy="2011680"/>
           </a:xfrm>
           <a:prstGeom prst="roundRect">
             <a:avLst/>
@@ -6353,17 +7369,17 @@
           <a:p>
             <a:pPr algn="ctr">
               <a:spcAft>
-                <a:spcPts val="400"/>
+                <a:spcPts val="600"/>
               </a:spcAft>
-              <a:defRPr sz="1700" b="1">
-                <a:solidFill>
-                  <a:srgbClr val="F59E0B"/>
-                </a:solidFill>
-                <a:latin typeface="Segoe UI"/>
-              </a:defRPr>
-            </a:pPr>
-            <a:r>
-              <a:t>Ingresso com QR Code Único</a:t>
+              <a:defRPr sz="1600" b="1">
+                <a:solidFill>
+                  <a:srgbClr val="FFFFFF"/>
+                </a:solidFill>
+                <a:latin typeface="Segoe UI"/>
+              </a:defRPr>
+            </a:pPr>
+            <a:r>
+              <a:t>Blindagem Restrita de Membresia</a:t>
             </a:r>
           </a:p>
           <a:p>
@@ -6376,21 +7392,21 @@
               </a:defRPr>
             </a:pPr>
             <a:r>
-              <a:t>Cada participante recebe seu ingresso digital nominal com QR Code seguro salvo no celular, sem necessidade de papel.</a:t>
-            </a:r>
-          </a:p>
-        </p:txBody>
-      </p:sp>
-      <p:sp>
-        <p:nvSpPr>
-          <p:cNvPr id="7" name="Rounded Rectangle 6"/>
+              <a:t>O sistema garante que novos cadastros convidados por membros recebam estritamente o papel de Membro, sem risco de acesso indevido.</a:t>
+            </a:r>
+          </a:p>
+        </p:txBody>
+      </p:sp>
+      <p:sp>
+        <p:nvSpPr>
+          <p:cNvPr id="8" name="Rounded Rectangle 7"/>
           <p:cNvSpPr/>
           <p:nvPr/>
         </p:nvSpPr>
         <p:spPr>
           <a:xfrm>
-            <a:off x="731520" y="4754879"/>
-            <a:ext cx="10725912" cy="1280160"/>
+            <a:off x="6217920" y="3977639"/>
+            <a:ext cx="5212080" cy="2011680"/>
           </a:xfrm>
           <a:prstGeom prst="roundRect">
             <a:avLst/>
@@ -6424,17 +7440,17 @@
           <a:p>
             <a:pPr algn="ctr">
               <a:spcAft>
-                <a:spcPts val="400"/>
+                <a:spcPts val="600"/>
               </a:spcAft>
-              <a:defRPr sz="1700" b="1">
-                <a:solidFill>
-                  <a:srgbClr val="F59E0B"/>
-                </a:solidFill>
-                <a:latin typeface="Segoe UI"/>
-              </a:defRPr>
-            </a:pPr>
-            <a:r>
-              <a:t>Check-in na Portaria em Segundos</a:t>
+              <a:defRPr sz="1600" b="1">
+                <a:solidFill>
+                  <a:srgbClr val="FFFFFF"/>
+                </a:solidFill>
+                <a:latin typeface="Segoe UI"/>
+              </a:defRPr>
+            </a:pPr>
+            <a:r>
+              <a:t>Acompanhamento pela Secretaria</a:t>
             </a:r>
           </a:p>
           <a:p>
@@ -6447,7 +7463,7 @@
               </a:defRPr>
             </a:pPr>
             <a:r>
-              <a:t>Os obreiros e voluntários realizam a leitura do QR Code na entrada usando a própria câmera do celular, eliminando filas e tumultos.</a:t>
+              <a:t>A liderança e a secretaria visualizam no painel quem convidou, quem aceitou e quando o novo membro concluiu seu cadastro.</a:t>
             </a:r>
           </a:p>
         </p:txBody>
@@ -6521,8 +7537,8 @@
         </p:nvSpPr>
         <p:spPr>
           <a:xfrm>
-            <a:off x="731520" y="457200"/>
-            <a:ext cx="10515600" cy="365760"/>
+            <a:off x="731520" y="411480"/>
+            <a:ext cx="10515600" cy="320040"/>
           </a:xfrm>
           <a:prstGeom prst="rect">
             <a:avLst/>
@@ -6557,7 +7573,7 @@
         </p:nvSpPr>
         <p:spPr>
           <a:xfrm>
-            <a:off x="731520" y="777240"/>
+            <a:off x="731520" y="731520"/>
             <a:ext cx="10515600" cy="731520"/>
           </a:xfrm>
           <a:prstGeom prst="rect">
@@ -6572,7 +7588,7 @@
           <a:lstStyle/>
           <a:p>
             <a:pPr>
-              <a:defRPr sz="2600" b="1">
+              <a:defRPr sz="2500" b="1">
                 <a:solidFill>
                   <a:srgbClr val="FFFFFF"/>
                 </a:solidFill>
@@ -6580,128 +7596,62 @@
               </a:defRPr>
             </a:pPr>
             <a:r>
-              <a:t>Segurança, Governança Ministerial e Sigilo Absoluto</a:t>
-            </a:r>
-          </a:p>
-        </p:txBody>
-      </p:sp>
-      <p:sp>
-        <p:nvSpPr>
-          <p:cNvPr id="5" name="Rounded Rectangle 4"/>
-          <p:cNvSpPr/>
+              <a:t>Gestão Financeira Transparente &amp; Comprovantes de Dízimo para IRPF</a:t>
+            </a:r>
+          </a:p>
+        </p:txBody>
+      </p:sp>
+      <p:pic>
+        <p:nvPicPr>
+          <p:cNvPr id="5" name="Picture 4" descr="gestao_eventos.jpg"/>
+          <p:cNvPicPr>
+            <a:picLocks noChangeAspect="1"/>
+          </p:cNvPicPr>
           <p:nvPr/>
-        </p:nvSpPr>
-        <p:spPr>
-          <a:xfrm>
-            <a:off x="731520" y="1737360"/>
-            <a:ext cx="5212080" cy="2011680"/>
-          </a:xfrm>
-          <a:prstGeom prst="roundRect">
+        </p:nvPicPr>
+        <p:blipFill>
+          <a:blip r:embed="rId2"/>
+          <a:stretch>
+            <a:fillRect/>
+          </a:stretch>
+        </p:blipFill>
+        <p:spPr>
+          <a:xfrm>
+            <a:off x="5303520" y="1554480"/>
+            <a:ext cx="6126480" cy="4572000"/>
+          </a:xfrm>
+          <a:prstGeom prst="rect">
             <a:avLst/>
           </a:prstGeom>
-          <a:solidFill>
-            <a:srgbClr val="121A2E"/>
-          </a:solidFill>
-          <a:ln w="12700">
-            <a:solidFill>
-              <a:srgbClr val="263455"/>
-            </a:solidFill>
-          </a:ln>
-        </p:spPr>
-        <p:style>
-          <a:lnRef idx="1">
-            <a:schemeClr val="accent1"/>
-          </a:lnRef>
-          <a:fillRef idx="3">
-            <a:schemeClr val="accent1"/>
-          </a:fillRef>
-          <a:effectRef idx="2">
-            <a:schemeClr val="accent1"/>
-          </a:effectRef>
-          <a:fontRef idx="minor">
-            <a:schemeClr val="lt1"/>
-          </a:fontRef>
-        </p:style>
-        <p:txBody>
-          <a:bodyPr rtlCol="0" anchor="ctr" wrap="square"/>
-          <a:lstStyle/>
-          <a:p>
-            <a:pPr algn="ctr">
-              <a:spcAft>
-                <a:spcPts val="600"/>
-              </a:spcAft>
-              <a:defRPr sz="1600" b="1">
-                <a:solidFill>
-                  <a:srgbClr val="F59E0B"/>
-                </a:solidFill>
-                <a:latin typeface="Segoe UI"/>
-              </a:defRPr>
-            </a:pPr>
-            <a:r>
-              <a:t>Pastor Titular / Presidente</a:t>
-            </a:r>
-          </a:p>
-          <a:p>
-            <a:pPr>
-              <a:defRPr sz="1300">
-                <a:solidFill>
-                  <a:srgbClr val="94A3B8"/>
-                </a:solidFill>
-                <a:latin typeface="Segoe UI"/>
-              </a:defRPr>
-            </a:pPr>
-            <a:r>
-              <a:t>Visão panorâmica estratégica, aprovação de líderes e relatórios globais de engajamento da igreja.</a:t>
-            </a:r>
-          </a:p>
-        </p:txBody>
-      </p:sp>
-      <p:sp>
-        <p:nvSpPr>
-          <p:cNvPr id="6" name="Rounded Rectangle 5"/>
-          <p:cNvSpPr/>
+        </p:spPr>
+      </p:pic>
+      <p:sp>
+        <p:nvSpPr>
+          <p:cNvPr id="6" name="TextBox 5"/>
+          <p:cNvSpPr txBox="1"/>
           <p:nvPr/>
         </p:nvSpPr>
         <p:spPr>
           <a:xfrm>
-            <a:off x="6217920" y="1737360"/>
-            <a:ext cx="5212080" cy="2011680"/>
-          </a:xfrm>
-          <a:prstGeom prst="roundRect">
+            <a:off x="731520" y="1508760"/>
+            <a:ext cx="4297680" cy="4663440"/>
+          </a:xfrm>
+          <a:prstGeom prst="rect">
             <a:avLst/>
           </a:prstGeom>
-          <a:solidFill>
-            <a:srgbClr val="121A2E"/>
-          </a:solidFill>
-          <a:ln w="12700">
-            <a:solidFill>
-              <a:srgbClr val="263455"/>
-            </a:solidFill>
-          </a:ln>
-        </p:spPr>
-        <p:style>
-          <a:lnRef idx="1">
-            <a:schemeClr val="accent1"/>
-          </a:lnRef>
-          <a:fillRef idx="3">
-            <a:schemeClr val="accent1"/>
-          </a:fillRef>
-          <a:effectRef idx="2">
-            <a:schemeClr val="accent1"/>
-          </a:effectRef>
-          <a:fontRef idx="minor">
-            <a:schemeClr val="lt1"/>
-          </a:fontRef>
-        </p:style>
-        <p:txBody>
-          <a:bodyPr rtlCol="0" anchor="ctr" wrap="square"/>
-          <a:lstStyle/>
-          <a:p>
-            <a:pPr algn="ctr">
+          <a:noFill/>
+        </p:spPr>
+        <p:txBody>
+          <a:bodyPr wrap="square">
+            <a:spAutoFit/>
+          </a:bodyPr>
+          <a:lstStyle/>
+          <a:p>
+            <a:pPr>
               <a:spcAft>
-                <a:spcPts val="600"/>
+                <a:spcPts val="200"/>
               </a:spcAft>
-              <a:defRPr sz="1600" b="1">
+              <a:defRPr sz="1400" b="1">
                 <a:solidFill>
                   <a:srgbClr val="F59E0B"/>
                 </a:solidFill>
@@ -6709,12 +7659,15 @@
               </a:defRPr>
             </a:pPr>
             <a:r>
-              <a:t>Tesouraria &amp; Conselho Fiscal</a:t>
-            </a:r>
-          </a:p>
-          <a:p>
-            <a:pPr>
-              <a:defRPr sz="1300">
+              <a:t>Dízimos e Ofertas Nominais:</a:t>
+            </a:r>
+          </a:p>
+          <a:p>
+            <a:pPr>
+              <a:spcAft>
+                <a:spcPts val="1000"/>
+              </a:spcAft>
+              <a:defRPr sz="1200">
                 <a:solidFill>
                   <a:srgbClr val="94A3B8"/>
                 </a:solidFill>
@@ -6722,57 +7675,15 @@
               </a:defRPr>
             </a:pPr>
             <a:r>
-              <a:t>Acesso exclusivo aos módulos financeiros e prestação de contas, sem acesso a dados sigilosos pastorais.</a:t>
-            </a:r>
-          </a:p>
-        </p:txBody>
-      </p:sp>
-      <p:sp>
-        <p:nvSpPr>
-          <p:cNvPr id="7" name="Rounded Rectangle 6"/>
-          <p:cNvSpPr/>
-          <p:nvPr/>
-        </p:nvSpPr>
-        <p:spPr>
-          <a:xfrm>
-            <a:off x="731520" y="4023360"/>
-            <a:ext cx="5212080" cy="2011680"/>
-          </a:xfrm>
-          <a:prstGeom prst="roundRect">
-            <a:avLst/>
-          </a:prstGeom>
-          <a:solidFill>
-            <a:srgbClr val="121A2E"/>
-          </a:solidFill>
-          <a:ln w="12700">
-            <a:solidFill>
-              <a:srgbClr val="263455"/>
-            </a:solidFill>
-          </a:ln>
-        </p:spPr>
-        <p:style>
-          <a:lnRef idx="1">
-            <a:schemeClr val="accent1"/>
-          </a:lnRef>
-          <a:fillRef idx="3">
-            <a:schemeClr val="accent1"/>
-          </a:fillRef>
-          <a:effectRef idx="2">
-            <a:schemeClr val="accent1"/>
-          </a:effectRef>
-          <a:fontRef idx="minor">
-            <a:schemeClr val="lt1"/>
-          </a:fontRef>
-        </p:style>
-        <p:txBody>
-          <a:bodyPr rtlCol="0" anchor="ctr" wrap="square"/>
-          <a:lstStyle/>
-          <a:p>
-            <a:pPr algn="ctr">
+              <a:t>Rastreamento seguro via PIX, cartão e transferências bancárias com identificação individual do membro.</a:t>
+            </a:r>
+          </a:p>
+          <a:p>
+            <a:pPr>
               <a:spcAft>
-                <a:spcPts val="600"/>
+                <a:spcPts val="200"/>
               </a:spcAft>
-              <a:defRPr sz="1600" b="1">
+              <a:defRPr sz="1400" b="1">
                 <a:solidFill>
                   <a:srgbClr val="F59E0B"/>
                 </a:solidFill>
@@ -6780,12 +7691,15 @@
               </a:defRPr>
             </a:pPr>
             <a:r>
-              <a:t>Líderes de Ministérios &amp; Células</a:t>
-            </a:r>
-          </a:p>
-          <a:p>
-            <a:pPr>
-              <a:defRPr sz="1300">
+              <a:t>Comprovante Anual para IRPF:</a:t>
+            </a:r>
+          </a:p>
+          <a:p>
+            <a:pPr>
+              <a:spcAft>
+                <a:spcPts val="1000"/>
+              </a:spcAft>
+              <a:defRPr sz="1200">
                 <a:solidFill>
                   <a:srgbClr val="94A3B8"/>
                 </a:solidFill>
@@ -6793,57 +7707,15 @@
               </a:defRPr>
             </a:pPr>
             <a:r>
-              <a:t>Gerenciam apenas os membros e eventos do seu ministério específico (Jovens, Casais, Kids, Células).</a:t>
-            </a:r>
-          </a:p>
-        </p:txBody>
-      </p:sp>
-      <p:sp>
-        <p:nvSpPr>
-          <p:cNvPr id="8" name="Rounded Rectangle 7"/>
-          <p:cNvSpPr/>
-          <p:nvPr/>
-        </p:nvSpPr>
-        <p:spPr>
-          <a:xfrm>
-            <a:off x="6217920" y="4023360"/>
-            <a:ext cx="5212080" cy="2011680"/>
-          </a:xfrm>
-          <a:prstGeom prst="roundRect">
-            <a:avLst/>
-          </a:prstGeom>
-          <a:solidFill>
-            <a:srgbClr val="121A2E"/>
-          </a:solidFill>
-          <a:ln w="12700">
-            <a:solidFill>
-              <a:srgbClr val="263455"/>
-            </a:solidFill>
-          </a:ln>
-        </p:spPr>
-        <p:style>
-          <a:lnRef idx="1">
-            <a:schemeClr val="accent1"/>
-          </a:lnRef>
-          <a:fillRef idx="3">
-            <a:schemeClr val="accent1"/>
-          </a:fillRef>
-          <a:effectRef idx="2">
-            <a:schemeClr val="accent1"/>
-          </a:effectRef>
-          <a:fontRef idx="minor">
-            <a:schemeClr val="lt1"/>
-          </a:fontRef>
-        </p:style>
-        <p:txBody>
-          <a:bodyPr rtlCol="0" anchor="ctr" wrap="square"/>
-          <a:lstStyle/>
-          <a:p>
-            <a:pPr algn="ctr">
+              <a:t>Gera extrato oficial com CNPJ da igreja para a declaração de Imposto de Renda dos membros de forma imediata.</a:t>
+            </a:r>
+          </a:p>
+          <a:p>
+            <a:pPr>
               <a:spcAft>
-                <a:spcPts val="600"/>
+                <a:spcPts val="200"/>
               </a:spcAft>
-              <a:defRPr sz="1600" b="1">
+              <a:defRPr sz="1400" b="1">
                 <a:solidFill>
                   <a:srgbClr val="F59E0B"/>
                 </a:solidFill>
@@ -6851,12 +7723,15 @@
               </a:defRPr>
             </a:pPr>
             <a:r>
-              <a:t>Membros da Congregação</a:t>
-            </a:r>
-          </a:p>
-          <a:p>
-            <a:pPr>
-              <a:defRPr sz="1300">
+              <a:t>Transparência com a Diretoria:</a:t>
+            </a:r>
+          </a:p>
+          <a:p>
+            <a:pPr>
+              <a:spcAft>
+                <a:spcPts val="1000"/>
+              </a:spcAft>
+              <a:defRPr sz="1200">
                 <a:solidFill>
                   <a:srgbClr val="94A3B8"/>
                 </a:solidFill>
@@ -6864,7 +7739,39 @@
               </a:defRPr>
             </a:pPr>
             <a:r>
-              <a:t>Acesso aos devocionais, células, pedidos de oração particulares e histórico dos seus próprios dízimos.</a:t>
+              <a:t>Relatórios mensais categorizados (Missões, Aluguel, Reforma, Obras Sociais) prontos para conselho fiscal e assembleia.</a:t>
+            </a:r>
+          </a:p>
+          <a:p>
+            <a:pPr>
+              <a:spcAft>
+                <a:spcPts val="200"/>
+              </a:spcAft>
+              <a:defRPr sz="1400" b="1">
+                <a:solidFill>
+                  <a:srgbClr val="F59E0B"/>
+                </a:solidFill>
+                <a:latin typeface="Segoe UI"/>
+              </a:defRPr>
+            </a:pPr>
+            <a:r>
+              <a:t>Segurança Bancária:</a:t>
+            </a:r>
+          </a:p>
+          <a:p>
+            <a:pPr>
+              <a:spcAft>
+                <a:spcPts val="1000"/>
+              </a:spcAft>
+              <a:defRPr sz="1200">
+                <a:solidFill>
+                  <a:srgbClr val="94A3B8"/>
+                </a:solidFill>
+                <a:latin typeface="Segoe UI"/>
+              </a:defRPr>
+            </a:pPr>
+            <a:r>
+              <a:t>Sem manipulação manual desprotegida de dinheiro em espécie na tesouraria.</a:t>
             </a:r>
           </a:p>
         </p:txBody>

</xml_diff>